<commit_message>
modification de mo power pour instruit PF
</commit_message>
<xml_diff>
--- a/Osis_Presentation_Ibrahim_SAVADOGO_2 [Autosaved].pptx
+++ b/Osis_Presentation_Ibrahim_SAVADOGO_2 [Autosaved].pptx
@@ -1179,6 +1179,481 @@
     <p:extLst>
       <p:ext uri="{BB962C8B-B14F-4D97-AF65-F5344CB8AC3E}">
         <p14:creationId xmlns:p14="http://schemas.microsoft.com/office/powerpoint/2010/main" val="337845281"/>
+      </p:ext>
+    </p:extLst>
+  </p:cSld>
+  <p:clrMapOvr>
+    <a:masterClrMapping/>
+  </p:clrMapOvr>
+</p:notes>
+</file>
+
+<file path=ppt/notesSlides/notesSlide4.xml><?xml version="1.0" encoding="utf-8"?>
+<p:notes xmlns:a="http://schemas.openxmlformats.org/drawingml/2006/main" xmlns:r="http://schemas.openxmlformats.org/officeDocument/2006/relationships" xmlns:p="http://schemas.openxmlformats.org/presentationml/2006/main">
+  <p:cSld>
+    <p:spTree>
+      <p:nvGrpSpPr>
+        <p:cNvPr id="1" name=""/>
+        <p:cNvGrpSpPr/>
+        <p:nvPr/>
+      </p:nvGrpSpPr>
+      <p:grpSpPr>
+        <a:xfrm>
+          <a:off x="0" y="0"/>
+          <a:ext cx="0" cy="0"/>
+          <a:chOff x="0" y="0"/>
+          <a:chExt cx="0" cy="0"/>
+        </a:xfrm>
+      </p:grpSpPr>
+      <p:sp>
+        <p:nvSpPr>
+          <p:cNvPr id="2" name="Slide Image Placeholder 1"/>
+          <p:cNvSpPr>
+            <a:spLocks noGrp="1" noRot="1" noChangeAspect="1"/>
+          </p:cNvSpPr>
+          <p:nvPr>
+            <p:ph type="sldImg"/>
+          </p:nvPr>
+        </p:nvSpPr>
+        <p:spPr/>
+      </p:sp>
+      <p:sp>
+        <p:nvSpPr>
+          <p:cNvPr id="3" name="Notes Placeholder 2"/>
+          <p:cNvSpPr>
+            <a:spLocks noGrp="1"/>
+          </p:cNvSpPr>
+          <p:nvPr>
+            <p:ph type="body" idx="1"/>
+          </p:nvPr>
+        </p:nvSpPr>
+        <p:spPr/>
+        <p:txBody>
+          <a:bodyPr/>
+          <a:lstStyle/>
+          <a:p>
+            <a:r>
+              <a:rPr lang="en-US" dirty="0" err="1" smtClean="0"/>
+              <a:t>Prorgammation</a:t>
+            </a:r>
+            <a:r>
+              <a:rPr lang="en-US" dirty="0" smtClean="0"/>
+              <a:t> </a:t>
+            </a:r>
+            <a:r>
+              <a:rPr lang="en-US" dirty="0" err="1" smtClean="0"/>
+              <a:t>fonctionnelle</a:t>
+            </a:r>
+            <a:r>
+              <a:rPr lang="en-US" baseline="0" dirty="0" smtClean="0"/>
+              <a:t> </a:t>
+            </a:r>
+            <a:r>
+              <a:rPr lang="en-US" baseline="0" dirty="0" err="1" smtClean="0"/>
+              <a:t>est</a:t>
+            </a:r>
+            <a:r>
+              <a:rPr lang="en-US" baseline="0" dirty="0" smtClean="0"/>
+              <a:t> un style de </a:t>
+            </a:r>
+            <a:r>
+              <a:rPr lang="en-US" baseline="0" dirty="0" err="1" smtClean="0"/>
+              <a:t>programmation</a:t>
+            </a:r>
+            <a:r>
+              <a:rPr lang="en-US" baseline="0" dirty="0" smtClean="0"/>
+              <a:t> </a:t>
+            </a:r>
+            <a:r>
+              <a:rPr lang="en-US" baseline="0" dirty="0" err="1" smtClean="0"/>
+              <a:t>en</a:t>
+            </a:r>
+            <a:r>
+              <a:rPr lang="en-US" baseline="0" dirty="0" smtClean="0"/>
+              <a:t> </a:t>
+            </a:r>
+            <a:r>
+              <a:rPr lang="en-US" baseline="0" dirty="0" err="1" smtClean="0"/>
+              <a:t>utilisant</a:t>
+            </a:r>
+            <a:r>
+              <a:rPr lang="en-US" baseline="0" dirty="0" smtClean="0"/>
+              <a:t> des </a:t>
+            </a:r>
+            <a:r>
+              <a:rPr lang="en-US" baseline="0" dirty="0" err="1" smtClean="0"/>
+              <a:t>fonctions</a:t>
+            </a:r>
+            <a:r>
+              <a:rPr lang="en-US" baseline="0" dirty="0" smtClean="0"/>
+              <a:t> </a:t>
+            </a:r>
+            <a:r>
+              <a:rPr lang="en-US" baseline="0" dirty="0" err="1" smtClean="0"/>
+              <a:t>mathematiques</a:t>
+            </a:r>
+            <a:r>
+              <a:rPr lang="en-US" baseline="0" dirty="0" smtClean="0"/>
+              <a:t> </a:t>
+            </a:r>
+            <a:r>
+              <a:rPr lang="en-US" baseline="0" dirty="0" err="1" smtClean="0"/>
+              <a:t>pures</a:t>
+            </a:r>
+            <a:r>
+              <a:rPr lang="en-US" baseline="0" dirty="0" smtClean="0"/>
+              <a:t> sans modifier </a:t>
+            </a:r>
+            <a:r>
+              <a:rPr lang="en-US" baseline="0" dirty="0" err="1" smtClean="0"/>
+              <a:t>l’eta</a:t>
+            </a:r>
+            <a:r>
+              <a:rPr lang="en-US" baseline="0" dirty="0" smtClean="0"/>
+              <a:t> du </a:t>
+            </a:r>
+            <a:r>
+              <a:rPr lang="en-US" baseline="0" dirty="0" err="1" smtClean="0"/>
+              <a:t>programmes</a:t>
+            </a:r>
+            <a:r>
+              <a:rPr lang="en-US" baseline="0" smtClean="0"/>
+              <a:t> </a:t>
+            </a:r>
+            <a:endParaRPr lang="en-US"/>
+          </a:p>
+        </p:txBody>
+      </p:sp>
+      <p:sp>
+        <p:nvSpPr>
+          <p:cNvPr id="4" name="Slide Number Placeholder 3"/>
+          <p:cNvSpPr>
+            <a:spLocks noGrp="1"/>
+          </p:cNvSpPr>
+          <p:nvPr>
+            <p:ph type="sldNum" sz="quarter" idx="10"/>
+          </p:nvPr>
+        </p:nvSpPr>
+        <p:spPr/>
+        <p:txBody>
+          <a:bodyPr/>
+          <a:lstStyle/>
+          <a:p>
+            <a:pPr>
+              <a:defRPr/>
+            </a:pPr>
+            <a:fld id="{4824BCD5-7DB3-4570-95FB-D6BD68920CD5}" type="slidenum">
+              <a:rPr lang="fr-CA" smtClean="0"/>
+              <a:pPr>
+                <a:defRPr/>
+              </a:pPr>
+              <a:t>7</a:t>
+            </a:fld>
+            <a:endParaRPr lang="fr-CA"/>
+          </a:p>
+        </p:txBody>
+      </p:sp>
+    </p:spTree>
+    <p:extLst>
+      <p:ext uri="{BB962C8B-B14F-4D97-AF65-F5344CB8AC3E}">
+        <p14:creationId xmlns:p14="http://schemas.microsoft.com/office/powerpoint/2010/main" val="2173265054"/>
+      </p:ext>
+    </p:extLst>
+  </p:cSld>
+  <p:clrMapOvr>
+    <a:masterClrMapping/>
+  </p:clrMapOvr>
+</p:notes>
+</file>
+
+<file path=ppt/notesSlides/notesSlide5.xml><?xml version="1.0" encoding="utf-8"?>
+<p:notes xmlns:a="http://schemas.openxmlformats.org/drawingml/2006/main" xmlns:r="http://schemas.openxmlformats.org/officeDocument/2006/relationships" xmlns:p="http://schemas.openxmlformats.org/presentationml/2006/main">
+  <p:cSld>
+    <p:spTree>
+      <p:nvGrpSpPr>
+        <p:cNvPr id="1" name=""/>
+        <p:cNvGrpSpPr/>
+        <p:nvPr/>
+      </p:nvGrpSpPr>
+      <p:grpSpPr>
+        <a:xfrm>
+          <a:off x="0" y="0"/>
+          <a:ext cx="0" cy="0"/>
+          <a:chOff x="0" y="0"/>
+          <a:chExt cx="0" cy="0"/>
+        </a:xfrm>
+      </p:grpSpPr>
+      <p:sp>
+        <p:nvSpPr>
+          <p:cNvPr id="2" name="Slide Image Placeholder 1"/>
+          <p:cNvSpPr>
+            <a:spLocks noGrp="1" noRot="1" noChangeAspect="1"/>
+          </p:cNvSpPr>
+          <p:nvPr>
+            <p:ph type="sldImg"/>
+          </p:nvPr>
+        </p:nvSpPr>
+        <p:spPr/>
+      </p:sp>
+      <p:sp>
+        <p:nvSpPr>
+          <p:cNvPr id="3" name="Notes Placeholder 2"/>
+          <p:cNvSpPr>
+            <a:spLocks noGrp="1"/>
+          </p:cNvSpPr>
+          <p:nvPr>
+            <p:ph type="body" idx="1"/>
+          </p:nvPr>
+        </p:nvSpPr>
+        <p:spPr/>
+        <p:txBody>
+          <a:bodyPr/>
+          <a:lstStyle/>
+          <a:p>
+            <a:r>
+              <a:rPr lang="fr-FR" dirty="0" smtClean="0"/>
+              <a:t>C'est une interface qui n'a </a:t>
+            </a:r>
+            <a:r>
+              <a:rPr lang="fr-FR" b="1" dirty="0" smtClean="0"/>
+              <a:t>qu'une seule méthode à implémenter</a:t>
+            </a:r>
+            <a:r>
+              <a:rPr lang="fr-FR" dirty="0" smtClean="0"/>
+              <a:t> — une seule obligation. Ni plus, ni moins.</a:t>
+            </a:r>
+          </a:p>
+          <a:p>
+            <a:r>
+              <a:rPr lang="fr-FR" dirty="0" smtClean="0"/>
+              <a:t>java</a:t>
+            </a:r>
+          </a:p>
+          <a:p>
+            <a:r>
+              <a:rPr lang="fr-FR" sz="1200" kern="1200" dirty="0" smtClean="0">
+                <a:solidFill>
+                  <a:schemeClr val="tx1"/>
+                </a:solidFill>
+                <a:effectLst/>
+                <a:latin typeface="Arial" charset="0"/>
+                <a:ea typeface="+mn-ea"/>
+                <a:cs typeface="+mn-cs"/>
+              </a:rPr>
+              <a:t>@</a:t>
+            </a:r>
+            <a:r>
+              <a:rPr lang="fr-FR" sz="1200" kern="1200" dirty="0" err="1" smtClean="0">
+                <a:solidFill>
+                  <a:schemeClr val="tx1"/>
+                </a:solidFill>
+                <a:effectLst/>
+                <a:latin typeface="Arial" charset="0"/>
+                <a:ea typeface="+mn-ea"/>
+                <a:cs typeface="+mn-cs"/>
+              </a:rPr>
+              <a:t>FunctionalInterface</a:t>
+            </a:r>
+            <a:r>
+              <a:rPr lang="fr-FR" dirty="0" smtClean="0"/>
+              <a:t> </a:t>
+            </a:r>
+            <a:r>
+              <a:rPr lang="fr-FR" sz="1200" kern="1200" dirty="0" smtClean="0">
+                <a:solidFill>
+                  <a:schemeClr val="tx1"/>
+                </a:solidFill>
+                <a:effectLst/>
+                <a:latin typeface="Arial" charset="0"/>
+                <a:ea typeface="+mn-ea"/>
+                <a:cs typeface="+mn-cs"/>
+              </a:rPr>
+              <a:t>interface</a:t>
+            </a:r>
+            <a:r>
+              <a:rPr lang="fr-FR" dirty="0" smtClean="0"/>
+              <a:t> </a:t>
+            </a:r>
+            <a:r>
+              <a:rPr lang="fr-FR" sz="1200" kern="1200" dirty="0" smtClean="0">
+                <a:solidFill>
+                  <a:schemeClr val="tx1"/>
+                </a:solidFill>
+                <a:effectLst/>
+                <a:latin typeface="Arial" charset="0"/>
+                <a:ea typeface="+mn-ea"/>
+                <a:cs typeface="+mn-cs"/>
+              </a:rPr>
+              <a:t>Calculateur</a:t>
+            </a:r>
+            <a:r>
+              <a:rPr lang="fr-FR" dirty="0" smtClean="0"/>
+              <a:t> </a:t>
+            </a:r>
+            <a:r>
+              <a:rPr lang="fr-FR" sz="1200" kern="1200" dirty="0" smtClean="0">
+                <a:solidFill>
+                  <a:schemeClr val="tx1"/>
+                </a:solidFill>
+                <a:effectLst/>
+                <a:latin typeface="Arial" charset="0"/>
+                <a:ea typeface="+mn-ea"/>
+                <a:cs typeface="+mn-cs"/>
+              </a:rPr>
+              <a:t>{</a:t>
+            </a:r>
+            <a:r>
+              <a:rPr lang="fr-FR" dirty="0" smtClean="0"/>
+              <a:t> </a:t>
+            </a:r>
+            <a:r>
+              <a:rPr lang="fr-FR" sz="1200" kern="1200" dirty="0" smtClean="0">
+                <a:solidFill>
+                  <a:schemeClr val="tx1"/>
+                </a:solidFill>
+                <a:effectLst/>
+                <a:latin typeface="Arial" charset="0"/>
+                <a:ea typeface="+mn-ea"/>
+                <a:cs typeface="+mn-cs"/>
+              </a:rPr>
+              <a:t>double</a:t>
+            </a:r>
+            <a:r>
+              <a:rPr lang="fr-FR" dirty="0" smtClean="0"/>
+              <a:t> </a:t>
+            </a:r>
+            <a:r>
+              <a:rPr lang="fr-FR" sz="1200" kern="1200" dirty="0" smtClean="0">
+                <a:solidFill>
+                  <a:schemeClr val="tx1"/>
+                </a:solidFill>
+                <a:effectLst/>
+                <a:latin typeface="Arial" charset="0"/>
+                <a:ea typeface="+mn-ea"/>
+                <a:cs typeface="+mn-cs"/>
+              </a:rPr>
+              <a:t>calculer(double</a:t>
+            </a:r>
+            <a:r>
+              <a:rPr lang="fr-FR" dirty="0" smtClean="0"/>
+              <a:t> a</a:t>
+            </a:r>
+            <a:r>
+              <a:rPr lang="fr-FR" sz="1200" kern="1200" dirty="0" smtClean="0">
+                <a:solidFill>
+                  <a:schemeClr val="tx1"/>
+                </a:solidFill>
+                <a:effectLst/>
+                <a:latin typeface="Arial" charset="0"/>
+                <a:ea typeface="+mn-ea"/>
+                <a:cs typeface="+mn-cs"/>
+              </a:rPr>
+              <a:t>,</a:t>
+            </a:r>
+            <a:r>
+              <a:rPr lang="fr-FR" dirty="0" smtClean="0"/>
+              <a:t> </a:t>
+            </a:r>
+            <a:r>
+              <a:rPr lang="fr-FR" sz="1200" kern="1200" dirty="0" smtClean="0">
+                <a:solidFill>
+                  <a:schemeClr val="tx1"/>
+                </a:solidFill>
+                <a:effectLst/>
+                <a:latin typeface="Arial" charset="0"/>
+                <a:ea typeface="+mn-ea"/>
+                <a:cs typeface="+mn-cs"/>
+              </a:rPr>
+              <a:t>double</a:t>
+            </a:r>
+            <a:r>
+              <a:rPr lang="fr-FR" dirty="0" smtClean="0"/>
+              <a:t> b</a:t>
+            </a:r>
+            <a:r>
+              <a:rPr lang="fr-FR" sz="1200" kern="1200" dirty="0" smtClean="0">
+                <a:solidFill>
+                  <a:schemeClr val="tx1"/>
+                </a:solidFill>
+                <a:effectLst/>
+                <a:latin typeface="Arial" charset="0"/>
+                <a:ea typeface="+mn-ea"/>
+                <a:cs typeface="+mn-cs"/>
+              </a:rPr>
+              <a:t>);</a:t>
+            </a:r>
+            <a:r>
+              <a:rPr lang="fr-FR" dirty="0" smtClean="0"/>
+              <a:t> </a:t>
+            </a:r>
+            <a:r>
+              <a:rPr lang="fr-FR" sz="1200" kern="1200" dirty="0" smtClean="0">
+                <a:solidFill>
+                  <a:schemeClr val="tx1"/>
+                </a:solidFill>
+                <a:effectLst/>
+                <a:latin typeface="Arial" charset="0"/>
+                <a:ea typeface="+mn-ea"/>
+                <a:cs typeface="+mn-cs"/>
+              </a:rPr>
+              <a:t>// la seule méthode obligatoire</a:t>
+            </a:r>
+            <a:r>
+              <a:rPr lang="fr-FR" dirty="0" smtClean="0"/>
+              <a:t> </a:t>
+            </a:r>
+            <a:r>
+              <a:rPr lang="fr-FR" sz="1200" kern="1200" dirty="0" smtClean="0">
+                <a:solidFill>
+                  <a:schemeClr val="tx1"/>
+                </a:solidFill>
+                <a:effectLst/>
+                <a:latin typeface="Arial" charset="0"/>
+                <a:ea typeface="+mn-ea"/>
+                <a:cs typeface="+mn-cs"/>
+              </a:rPr>
+              <a:t>}</a:t>
+            </a:r>
+            <a:endParaRPr lang="fr-FR" dirty="0" smtClean="0"/>
+          </a:p>
+          <a:p>
+            <a:endParaRPr lang="en-US" dirty="0"/>
+          </a:p>
+        </p:txBody>
+      </p:sp>
+      <p:sp>
+        <p:nvSpPr>
+          <p:cNvPr id="4" name="Slide Number Placeholder 3"/>
+          <p:cNvSpPr>
+            <a:spLocks noGrp="1"/>
+          </p:cNvSpPr>
+          <p:nvPr>
+            <p:ph type="sldNum" sz="quarter" idx="10"/>
+          </p:nvPr>
+        </p:nvSpPr>
+        <p:spPr/>
+        <p:txBody>
+          <a:bodyPr/>
+          <a:lstStyle/>
+          <a:p>
+            <a:pPr>
+              <a:defRPr/>
+            </a:pPr>
+            <a:fld id="{4824BCD5-7DB3-4570-95FB-D6BD68920CD5}" type="slidenum">
+              <a:rPr lang="fr-CA" smtClean="0"/>
+              <a:pPr>
+                <a:defRPr/>
+              </a:pPr>
+              <a:t>9</a:t>
+            </a:fld>
+            <a:endParaRPr lang="fr-CA"/>
+          </a:p>
+        </p:txBody>
+      </p:sp>
+    </p:spTree>
+    <p:extLst>
+      <p:ext uri="{BB962C8B-B14F-4D97-AF65-F5344CB8AC3E}">
+        <p14:creationId xmlns:p14="http://schemas.microsoft.com/office/powerpoint/2010/main" val="3338016904"/>
       </p:ext>
     </p:extLst>
   </p:cSld>
@@ -4278,7 +4753,7 @@
         <p:spPr>
           <a:xfrm>
             <a:off x="827584" y="332656"/>
-            <a:ext cx="3108736" cy="461665"/>
+            <a:ext cx="4048096" cy="461665"/>
           </a:xfrm>
           <a:prstGeom prst="rect">
             <a:avLst/>
@@ -4291,10 +4766,11 @@
           <a:lstStyle/>
           <a:p>
             <a:r>
-              <a:rPr lang="fr-CI" b="1" dirty="0" smtClean="0">
+              <a:rPr lang="fr-CI" sz="2400" b="1" dirty="0" smtClean="0">
                 <a:solidFill>
                   <a:srgbClr val="FF0000"/>
                 </a:solidFill>
+                <a:latin typeface="+mn-lt"/>
               </a:rPr>
               <a:t>IV. Tour d’horizon d’un IDE</a:t>
             </a:r>
@@ -4302,6 +4778,7 @@
               <a:solidFill>
                 <a:srgbClr val="FF0000"/>
               </a:solidFill>
+              <a:latin typeface="+mn-lt"/>
             </a:endParaRPr>
           </a:p>
         </p:txBody>
@@ -5211,6 +5688,7 @@
                 <a:solidFill>
                   <a:srgbClr val="FF0000"/>
                 </a:solidFill>
+                <a:latin typeface="+mn-lt"/>
               </a:rPr>
               <a:t>I. JAVA 8 : Nouveauté du langage</a:t>
             </a:r>
@@ -5218,6 +5696,7 @@
               <a:solidFill>
                 <a:srgbClr val="FF0000"/>
               </a:solidFill>
+              <a:latin typeface="+mn-lt"/>
             </a:endParaRPr>
           </a:p>
         </p:txBody>
@@ -5860,10 +6339,13 @@
                 <a:solidFill>
                   <a:srgbClr val="FF0000"/>
                 </a:solidFill>
+                <a:latin typeface="+mn-lt"/>
               </a:rPr>
               <a:t>II.1 Classe Abstraites</a:t>
             </a:r>
-            <a:endParaRPr lang="en-US" sz="2400" dirty="0"/>
+            <a:endParaRPr lang="en-US" sz="2400" dirty="0">
+              <a:latin typeface="+mn-lt"/>
+            </a:endParaRPr>
           </a:p>
         </p:txBody>
       </p:sp>
@@ -7020,10 +7502,13 @@
                 <a:solidFill>
                   <a:srgbClr val="FF0000"/>
                 </a:solidFill>
+                <a:latin typeface="+mn-lt"/>
               </a:rPr>
               <a:t>II.2 Classe Interfaces</a:t>
             </a:r>
-            <a:endParaRPr lang="en-US" sz="2400" dirty="0"/>
+            <a:endParaRPr lang="en-US" sz="2400" dirty="0">
+              <a:latin typeface="+mn-lt"/>
+            </a:endParaRPr>
           </a:p>
         </p:txBody>
       </p:sp>
@@ -7851,7 +8336,7 @@
         <p:spPr>
           <a:xfrm>
             <a:off x="827584" y="332656"/>
-            <a:ext cx="3249608" cy="461665"/>
+            <a:ext cx="4153701" cy="461665"/>
           </a:xfrm>
           <a:prstGeom prst="rect">
             <a:avLst/>
@@ -7864,18 +8349,20 @@
           <a:lstStyle/>
           <a:p>
             <a:r>
-              <a:rPr lang="fr-CI" b="1" dirty="0" smtClean="0">
+              <a:rPr lang="fr-CI" sz="2400" b="1" dirty="0" smtClean="0">
                 <a:solidFill>
                   <a:srgbClr val="FF0000"/>
                 </a:solidFill>
+                <a:latin typeface="+mn-lt"/>
               </a:rPr>
               <a:t>II.3 Gestion </a:t>
             </a:r>
             <a:r>
-              <a:rPr lang="fr-CI" b="1" dirty="0">
+              <a:rPr lang="fr-CI" sz="2400" b="1" dirty="0">
                 <a:solidFill>
                   <a:srgbClr val="FF0000"/>
                 </a:solidFill>
+                <a:latin typeface="+mn-lt"/>
               </a:rPr>
               <a:t>des Exceptions </a:t>
             </a:r>
@@ -7883,6 +8370,7 @@
               <a:solidFill>
                 <a:srgbClr val="FF0000"/>
               </a:solidFill>
+              <a:latin typeface="+mn-lt"/>
             </a:endParaRPr>
           </a:p>
         </p:txBody>
@@ -9467,7 +9955,7 @@
         <p:spPr>
           <a:xfrm>
             <a:off x="827584" y="332656"/>
-            <a:ext cx="5878532" cy="461665"/>
+            <a:ext cx="7661072" cy="461665"/>
           </a:xfrm>
           <a:prstGeom prst="rect">
             <a:avLst/>
@@ -9480,26 +9968,29 @@
           <a:lstStyle/>
           <a:p>
             <a:r>
-              <a:rPr lang="fr-CI" b="1" dirty="0" smtClean="0">
+              <a:rPr lang="fr-CI" sz="2400" b="1" dirty="0" smtClean="0">
                 <a:solidFill>
                   <a:srgbClr val="FF0000"/>
                 </a:solidFill>
+                <a:latin typeface="+mn-lt"/>
               </a:rPr>
               <a:t>III. Programmation fonctionnelle (</a:t>
             </a:r>
             <a:r>
-              <a:rPr lang="fr-CI" b="1" dirty="0" err="1" smtClean="0">
+              <a:rPr lang="fr-CI" sz="2400" b="1" dirty="0" err="1" smtClean="0">
                 <a:solidFill>
                   <a:srgbClr val="FF0000"/>
                 </a:solidFill>
+                <a:latin typeface="+mn-lt"/>
               </a:rPr>
               <a:t>lamda</a:t>
             </a:r>
             <a:r>
-              <a:rPr lang="fr-CI" b="1" dirty="0" smtClean="0">
+              <a:rPr lang="fr-CI" sz="2400" b="1" dirty="0" smtClean="0">
                 <a:solidFill>
                   <a:srgbClr val="FF0000"/>
                 </a:solidFill>
+                <a:latin typeface="+mn-lt"/>
               </a:rPr>
               <a:t> expression)</a:t>
             </a:r>
@@ -9507,6 +9998,7 @@
               <a:solidFill>
                 <a:srgbClr val="FF0000"/>
               </a:solidFill>
+              <a:latin typeface="+mn-lt"/>
             </a:endParaRPr>
           </a:p>
         </p:txBody>
@@ -9772,7 +10264,7 @@
           <p:nvPr/>
         </p:nvPicPr>
         <p:blipFill>
-          <a:blip r:embed="rId2" cstate="print">
+          <a:blip r:embed="rId3" cstate="print">
             <a:extLst>
               <a:ext uri="{28A0092B-C50C-407E-A947-70E740481C1C}">
                 <a14:useLocalDpi xmlns:a14="http://schemas.microsoft.com/office/drawing/2010/main" val="0"/>
@@ -9838,8 +10330,8 @@
         </p:nvSpPr>
         <p:spPr>
           <a:xfrm>
-            <a:off x="827584" y="332656"/>
-            <a:ext cx="5878532" cy="461665"/>
+            <a:off x="755576" y="188640"/>
+            <a:ext cx="7661072" cy="461665"/>
           </a:xfrm>
           <a:prstGeom prst="rect">
             <a:avLst/>
@@ -9852,26 +10344,29 @@
           <a:lstStyle/>
           <a:p>
             <a:r>
-              <a:rPr lang="fr-CI" b="1" dirty="0" smtClean="0">
+              <a:rPr lang="fr-CI" sz="2400" b="1" dirty="0" smtClean="0">
                 <a:solidFill>
                   <a:srgbClr val="FF0000"/>
                 </a:solidFill>
+                <a:latin typeface="+mn-lt"/>
               </a:rPr>
               <a:t>III. Programmation fonctionnelle (</a:t>
             </a:r>
             <a:r>
-              <a:rPr lang="fr-CI" b="1" dirty="0" err="1" smtClean="0">
+              <a:rPr lang="fr-CI" sz="2400" b="1" dirty="0" err="1" smtClean="0">
                 <a:solidFill>
                   <a:srgbClr val="FF0000"/>
                 </a:solidFill>
+                <a:latin typeface="+mn-lt"/>
               </a:rPr>
               <a:t>lamda</a:t>
             </a:r>
             <a:r>
-              <a:rPr lang="fr-CI" b="1" dirty="0" smtClean="0">
+              <a:rPr lang="fr-CI" sz="2400" b="1" dirty="0" smtClean="0">
                 <a:solidFill>
                   <a:srgbClr val="FF0000"/>
                 </a:solidFill>
+                <a:latin typeface="+mn-lt"/>
               </a:rPr>
               <a:t> expression)</a:t>
             </a:r>
@@ -9879,6 +10374,7 @@
               <a:solidFill>
                 <a:srgbClr val="FF0000"/>
               </a:solidFill>
+              <a:latin typeface="+mn-lt"/>
             </a:endParaRPr>
           </a:p>
         </p:txBody>
@@ -9893,8 +10389,8 @@
         </p:nvSpPr>
         <p:spPr bwMode="auto">
           <a:xfrm>
-            <a:off x="395536" y="1464461"/>
-            <a:ext cx="8748464" cy="2862322"/>
+            <a:off x="395536" y="1110224"/>
+            <a:ext cx="7344816" cy="4401205"/>
           </a:xfrm>
           <a:prstGeom prst="rect">
             <a:avLst/>
@@ -10051,7 +10547,7 @@
               <a:tabLst/>
             </a:pPr>
             <a:r>
-              <a:rPr kumimoji="0" lang="en-US" altLang="en-US" sz="2000" b="1" i="0" u="none" strike="noStrike" cap="none" normalizeH="0" baseline="0" dirty="0" err="1" smtClean="0">
+              <a:rPr kumimoji="0" lang="en-US" altLang="en-US" sz="2000" b="1" i="0" u="sng" strike="noStrike" cap="none" normalizeH="0" baseline="0" dirty="0" err="1" smtClean="0">
                 <a:ln>
                   <a:noFill/>
                 </a:ln>
@@ -10065,7 +10561,7 @@
               <a:t>Exemple</a:t>
             </a:r>
             <a:r>
-              <a:rPr kumimoji="0" lang="en-US" altLang="en-US" sz="2000" b="1" i="0" u="none" strike="noStrike" cap="none" normalizeH="0" baseline="0" dirty="0" smtClean="0">
+              <a:rPr kumimoji="0" lang="en-US" altLang="en-US" sz="2000" b="1" i="0" u="sng" strike="noStrike" cap="none" normalizeH="0" baseline="0" dirty="0" smtClean="0">
                 <a:ln>
                   <a:noFill/>
                 </a:ln>
@@ -10109,9 +10605,9 @@
             </a:endParaRPr>
           </a:p>
           <a:p>
-            <a:pPr marL="0" marR="0" lvl="0" indent="0" algn="l" defTabSz="914400" rtl="0" eaLnBrk="0" fontAlgn="base" latinLnBrk="0" hangingPunct="0">
+            <a:pPr marL="0" marR="0" lvl="0" indent="0" algn="just" defTabSz="914400" rtl="0" eaLnBrk="0" fontAlgn="base" latinLnBrk="0" hangingPunct="0">
               <a:lnSpc>
-                <a:spcPct val="100000"/>
+                <a:spcPct val="150000"/>
               </a:lnSpc>
               <a:spcBef>
                 <a:spcPct val="0"/>
@@ -10318,38 +10814,6 @@
               <a:latin typeface="Times New Roman" panose="02020603050405020304" pitchFamily="18" charset="0"/>
               <a:cs typeface="Times New Roman" panose="02020603050405020304" pitchFamily="18" charset="0"/>
             </a:endParaRPr>
-          </a:p>
-          <a:p>
-            <a:pPr marL="0" marR="0" lvl="0" indent="0" algn="l" defTabSz="914400" rtl="0" eaLnBrk="0" fontAlgn="base" latinLnBrk="0" hangingPunct="0">
-              <a:lnSpc>
-                <a:spcPct val="100000"/>
-              </a:lnSpc>
-              <a:spcBef>
-                <a:spcPct val="0"/>
-              </a:spcBef>
-              <a:spcAft>
-                <a:spcPct val="0"/>
-              </a:spcAft>
-              <a:buClrTx/>
-              <a:buSzTx/>
-              <a:buFontTx/>
-              <a:buNone/>
-              <a:tabLst/>
-            </a:pPr>
-            <a:r>
-              <a:rPr kumimoji="0" lang="en-US" altLang="en-US" sz="2000" b="0" i="0" u="none" strike="noStrike" cap="none" normalizeH="0" baseline="0" dirty="0" smtClean="0">
-                <a:ln>
-                  <a:noFill/>
-                </a:ln>
-                <a:solidFill>
-                  <a:srgbClr val="0A0A0A"/>
-                </a:solidFill>
-                <a:effectLst/>
-                <a:latin typeface="Times New Roman" panose="02020603050405020304" pitchFamily="18" charset="0"/>
-                <a:cs typeface="Times New Roman" panose="02020603050405020304" pitchFamily="18" charset="0"/>
-              </a:rPr>
-              <a:t>Java</a:t>
-            </a:r>
           </a:p>
           <a:p>
             <a:pPr marL="0" marR="0" lvl="0" indent="0" algn="l" defTabSz="914400" rtl="0" eaLnBrk="0" fontAlgn="base" latinLnBrk="0" hangingPunct="0">
@@ -10396,60 +10860,40 @@
                 <a:latin typeface="Times New Roman" panose="02020603050405020304" pitchFamily="18" charset="0"/>
                 <a:cs typeface="Times New Roman" panose="02020603050405020304" pitchFamily="18" charset="0"/>
               </a:rPr>
-              <a:t>     </a:t>
-            </a:r>
-            <a:r>
-              <a:rPr lang="en-US" altLang="en-US" sz="2000" dirty="0" err="1" smtClean="0">
+              <a:t>  </a:t>
+            </a:r>
+            <a:r>
+              <a:rPr lang="en-US" altLang="en-US" sz="2000" dirty="0" smtClean="0">
                 <a:solidFill>
                   <a:srgbClr val="0A0A0A"/>
                 </a:solidFill>
                 <a:latin typeface="Times New Roman" panose="02020603050405020304" pitchFamily="18" charset="0"/>
                 <a:cs typeface="Times New Roman" panose="02020603050405020304" pitchFamily="18" charset="0"/>
               </a:rPr>
-              <a:t>noms</a:t>
-            </a:r>
-            <a:r>
-              <a:rPr lang="en-US" altLang="en-US" sz="2000" dirty="0" smtClean="0">
+              <a:t>noms </a:t>
+            </a:r>
+            <a:r>
+              <a:rPr lang="en-US" altLang="en-US" sz="2000" dirty="0">
                 <a:solidFill>
                   <a:srgbClr val="0A0A0A"/>
                 </a:solidFill>
                 <a:latin typeface="Times New Roman" panose="02020603050405020304" pitchFamily="18" charset="0"/>
                 <a:cs typeface="Times New Roman" panose="02020603050405020304" pitchFamily="18" charset="0"/>
               </a:rPr>
-              <a:t> </a:t>
-            </a:r>
-            <a:r>
-              <a:rPr lang="en-US" altLang="en-US" sz="2000" dirty="0">
+              <a:t>= </a:t>
+            </a:r>
+            <a:r>
+              <a:rPr lang="en-US" altLang="en-US" sz="2000" b="1" dirty="0">
                 <a:solidFill>
                   <a:srgbClr val="0A0A0A"/>
                 </a:solidFill>
                 <a:latin typeface="Times New Roman" panose="02020603050405020304" pitchFamily="18" charset="0"/>
                 <a:cs typeface="Times New Roman" panose="02020603050405020304" pitchFamily="18" charset="0"/>
               </a:rPr>
-              <a:t>= </a:t>
-            </a:r>
-            <a:r>
-              <a:rPr lang="en-US" altLang="en-US" sz="2000" dirty="0" err="1">
-                <a:solidFill>
-                  <a:srgbClr val="0A0A0A"/>
-                </a:solidFill>
-                <a:latin typeface="Times New Roman" panose="02020603050405020304" pitchFamily="18" charset="0"/>
-                <a:cs typeface="Times New Roman" panose="02020603050405020304" pitchFamily="18" charset="0"/>
-              </a:rPr>
-              <a:t>Arrays.asList</a:t>
-            </a:r>
-            <a:r>
-              <a:rPr lang="en-US" altLang="en-US" sz="2000" dirty="0">
-                <a:solidFill>
-                  <a:srgbClr val="0A0A0A"/>
-                </a:solidFill>
-                <a:latin typeface="Times New Roman" panose="02020603050405020304" pitchFamily="18" charset="0"/>
-                <a:cs typeface="Times New Roman" panose="02020603050405020304" pitchFamily="18" charset="0"/>
-              </a:rPr>
-              <a:t>("Alice", "Bob", "Charlie</a:t>
-            </a:r>
-            <a:r>
-              <a:rPr lang="en-US" altLang="en-US" sz="2000" dirty="0" smtClean="0">
+              <a:t>Arrays.asList("Alice", "Bob", "Charlie</a:t>
+            </a:r>
+            <a:r>
+              <a:rPr lang="en-US" altLang="en-US" sz="2000" b="1" dirty="0" smtClean="0">
                 <a:solidFill>
                   <a:srgbClr val="0A0A0A"/>
                 </a:solidFill>
@@ -10470,16 +10914,74 @@
             </a:endParaRPr>
           </a:p>
           <a:p>
-            <a:pPr lvl="0"/>
+            <a:pPr lvl="0">
+              <a:lnSpc>
+                <a:spcPct val="150000"/>
+              </a:lnSpc>
+            </a:pPr>
             <a:r>
               <a:rPr lang="en-US" altLang="en-US" sz="2000" b="1" dirty="0" err="1" smtClean="0">
                 <a:solidFill>
+                  <a:srgbClr val="FF0000"/>
+                </a:solidFill>
+                <a:latin typeface="Times New Roman" panose="02020603050405020304" pitchFamily="18" charset="0"/>
+                <a:cs typeface="Times New Roman" panose="02020603050405020304" pitchFamily="18" charset="0"/>
+              </a:rPr>
+              <a:t>noms.stream</a:t>
+            </a:r>
+            <a:r>
+              <a:rPr lang="en-US" altLang="en-US" sz="2000" b="1" dirty="0">
+                <a:solidFill>
+                  <a:srgbClr val="FF0000"/>
+                </a:solidFill>
+                <a:latin typeface="Times New Roman" panose="02020603050405020304" pitchFamily="18" charset="0"/>
+                <a:cs typeface="Times New Roman" panose="02020603050405020304" pitchFamily="18" charset="0"/>
+              </a:rPr>
+              <a:t>() </a:t>
+            </a:r>
+            <a:endParaRPr lang="en-US" altLang="en-US" sz="2000" b="1" dirty="0" smtClean="0">
+              <a:solidFill>
+                <a:srgbClr val="FF0000"/>
+              </a:solidFill>
+              <a:latin typeface="Times New Roman" panose="02020603050405020304" pitchFamily="18" charset="0"/>
+              <a:cs typeface="Times New Roman" panose="02020603050405020304" pitchFamily="18" charset="0"/>
+            </a:endParaRPr>
+          </a:p>
+          <a:p>
+            <a:pPr lvl="0">
+              <a:lnSpc>
+                <a:spcPct val="150000"/>
+              </a:lnSpc>
+            </a:pPr>
+            <a:r>
+              <a:rPr lang="en-US" altLang="en-US" sz="2000" b="1" dirty="0" smtClean="0">
+                <a:solidFill>
+                  <a:srgbClr val="FF0000"/>
+                </a:solidFill>
+                <a:latin typeface="Times New Roman" panose="02020603050405020304" pitchFamily="18" charset="0"/>
+                <a:cs typeface="Times New Roman" panose="02020603050405020304" pitchFamily="18" charset="0"/>
+              </a:rPr>
+              <a:t> </a:t>
+            </a:r>
+            <a:r>
+              <a:rPr lang="en-US" altLang="en-US" sz="2000" b="1" dirty="0">
+                <a:solidFill>
                   <a:srgbClr val="0A0A0A"/>
                 </a:solidFill>
                 <a:latin typeface="Times New Roman" panose="02020603050405020304" pitchFamily="18" charset="0"/>
                 <a:cs typeface="Times New Roman" panose="02020603050405020304" pitchFamily="18" charset="0"/>
               </a:rPr>
-              <a:t>noms.stream</a:t>
+              <a:t>.filter(nom -&gt; </a:t>
+            </a:r>
+            <a:r>
+              <a:rPr lang="en-US" altLang="en-US" sz="2000" b="1" dirty="0" err="1">
+                <a:solidFill>
+                  <a:srgbClr val="0A0A0A"/>
+                </a:solidFill>
+                <a:latin typeface="Times New Roman" panose="02020603050405020304" pitchFamily="18" charset="0"/>
+                <a:cs typeface="Times New Roman" panose="02020603050405020304" pitchFamily="18" charset="0"/>
+              </a:rPr>
+              <a:t>nom.startsWith</a:t>
             </a:r>
             <a:r>
               <a:rPr lang="en-US" altLang="en-US" sz="2000" b="1" dirty="0">
@@ -10489,7 +10991,7 @@
                 <a:latin typeface="Times New Roman" panose="02020603050405020304" pitchFamily="18" charset="0"/>
                 <a:cs typeface="Times New Roman" panose="02020603050405020304" pitchFamily="18" charset="0"/>
               </a:rPr>
-              <a:t>() </a:t>
+              <a:t>("A</a:t>
             </a:r>
             <a:r>
               <a:rPr lang="en-US" altLang="en-US" sz="2000" b="1" dirty="0" smtClean="0">
@@ -10499,7 +11001,24 @@
                 <a:latin typeface="Times New Roman" panose="02020603050405020304" pitchFamily="18" charset="0"/>
                 <a:cs typeface="Times New Roman" panose="02020603050405020304" pitchFamily="18" charset="0"/>
               </a:rPr>
-              <a:t> </a:t>
+              <a:t>"))</a:t>
+            </a:r>
+          </a:p>
+          <a:p>
+            <a:pPr lvl="0">
+              <a:lnSpc>
+                <a:spcPct val="150000"/>
+              </a:lnSpc>
+            </a:pPr>
+            <a:r>
+              <a:rPr lang="en-US" altLang="en-US" sz="2000" b="1" dirty="0" smtClean="0">
+                <a:solidFill>
+                  <a:srgbClr val="0A0A0A"/>
+                </a:solidFill>
+                <a:latin typeface="Times New Roman" panose="02020603050405020304" pitchFamily="18" charset="0"/>
+                <a:cs typeface="Times New Roman" panose="02020603050405020304" pitchFamily="18" charset="0"/>
+              </a:rPr>
+              <a:t>.</a:t>
             </a:r>
             <a:r>
               <a:rPr lang="en-US" altLang="en-US" sz="2000" b="1" dirty="0">
@@ -10509,7 +11028,7 @@
                 <a:latin typeface="Times New Roman" panose="02020603050405020304" pitchFamily="18" charset="0"/>
                 <a:cs typeface="Times New Roman" panose="02020603050405020304" pitchFamily="18" charset="0"/>
               </a:rPr>
-              <a:t>.filter(nom -&gt; </a:t>
+              <a:t>map(nom -&gt; </a:t>
             </a:r>
             <a:r>
               <a:rPr lang="en-US" altLang="en-US" sz="2000" b="1" dirty="0" err="1">
@@ -10519,18 +11038,25 @@
                 <a:latin typeface="Times New Roman" panose="02020603050405020304" pitchFamily="18" charset="0"/>
                 <a:cs typeface="Times New Roman" panose="02020603050405020304" pitchFamily="18" charset="0"/>
               </a:rPr>
-              <a:t>nom.startsWith</a:t>
-            </a:r>
-            <a:r>
-              <a:rPr lang="en-US" altLang="en-US" sz="2000" b="1" dirty="0">
+              <a:t>nom.toUpperCase</a:t>
+            </a:r>
+            <a:r>
+              <a:rPr lang="en-US" altLang="en-US" sz="2000" b="1" dirty="0" smtClean="0">
                 <a:solidFill>
                   <a:srgbClr val="0A0A0A"/>
                 </a:solidFill>
                 <a:latin typeface="Times New Roman" panose="02020603050405020304" pitchFamily="18" charset="0"/>
                 <a:cs typeface="Times New Roman" panose="02020603050405020304" pitchFamily="18" charset="0"/>
               </a:rPr>
-              <a:t>("A</a:t>
-            </a:r>
+              <a:t>())</a:t>
+            </a:r>
+          </a:p>
+          <a:p>
+            <a:pPr lvl="0">
+              <a:lnSpc>
+                <a:spcPct val="150000"/>
+              </a:lnSpc>
+            </a:pPr>
             <a:r>
               <a:rPr lang="en-US" altLang="en-US" sz="2000" b="1" dirty="0" smtClean="0">
                 <a:solidFill>
@@ -10539,37 +11065,7 @@
                 <a:latin typeface="Times New Roman" panose="02020603050405020304" pitchFamily="18" charset="0"/>
                 <a:cs typeface="Times New Roman" panose="02020603050405020304" pitchFamily="18" charset="0"/>
               </a:rPr>
-              <a:t>")).</a:t>
-            </a:r>
-            <a:r>
-              <a:rPr lang="en-US" altLang="en-US" sz="2000" b="1" dirty="0">
-                <a:solidFill>
-                  <a:srgbClr val="0A0A0A"/>
-                </a:solidFill>
-                <a:latin typeface="Times New Roman" panose="02020603050405020304" pitchFamily="18" charset="0"/>
-                <a:cs typeface="Times New Roman" panose="02020603050405020304" pitchFamily="18" charset="0"/>
-              </a:rPr>
-              <a:t>map(nom -&gt; </a:t>
-            </a:r>
-            <a:r>
-              <a:rPr lang="en-US" altLang="en-US" sz="2000" b="1" dirty="0" err="1">
-                <a:solidFill>
-                  <a:srgbClr val="0A0A0A"/>
-                </a:solidFill>
-                <a:latin typeface="Times New Roman" panose="02020603050405020304" pitchFamily="18" charset="0"/>
-                <a:cs typeface="Times New Roman" panose="02020603050405020304" pitchFamily="18" charset="0"/>
-              </a:rPr>
-              <a:t>nom.toUpperCase</a:t>
-            </a:r>
-            <a:r>
-              <a:rPr lang="en-US" altLang="en-US" sz="2000" b="1" dirty="0" smtClean="0">
-                <a:solidFill>
-                  <a:srgbClr val="0A0A0A"/>
-                </a:solidFill>
-                <a:latin typeface="Times New Roman" panose="02020603050405020304" pitchFamily="18" charset="0"/>
-                <a:cs typeface="Times New Roman" panose="02020603050405020304" pitchFamily="18" charset="0"/>
-              </a:rPr>
-              <a:t>()).</a:t>
+              <a:t>.</a:t>
             </a:r>
             <a:r>
               <a:rPr lang="en-US" altLang="en-US" sz="2000" b="1" dirty="0" err="1">
@@ -10727,7 +11223,7 @@
         <p:spPr>
           <a:xfrm>
             <a:off x="827584" y="332656"/>
-            <a:ext cx="5878532" cy="461665"/>
+            <a:ext cx="7661072" cy="461665"/>
           </a:xfrm>
           <a:prstGeom prst="rect">
             <a:avLst/>
@@ -10740,26 +11236,29 @@
           <a:lstStyle/>
           <a:p>
             <a:r>
-              <a:rPr lang="fr-CI" b="1" dirty="0" smtClean="0">
+              <a:rPr lang="fr-CI" sz="2400" b="1" dirty="0" smtClean="0">
                 <a:solidFill>
                   <a:srgbClr val="FF0000"/>
                 </a:solidFill>
+                <a:latin typeface="+mn-lt"/>
               </a:rPr>
               <a:t>III. Programmation fonctionnelle (</a:t>
             </a:r>
             <a:r>
-              <a:rPr lang="fr-CI" b="1" dirty="0" err="1" smtClean="0">
+              <a:rPr lang="fr-CI" sz="2400" b="1" dirty="0" err="1" smtClean="0">
                 <a:solidFill>
                   <a:srgbClr val="FF0000"/>
                 </a:solidFill>
+                <a:latin typeface="+mn-lt"/>
               </a:rPr>
               <a:t>lamda</a:t>
             </a:r>
             <a:r>
-              <a:rPr lang="fr-CI" b="1" dirty="0" smtClean="0">
+              <a:rPr lang="fr-CI" sz="2400" b="1" dirty="0" smtClean="0">
                 <a:solidFill>
                   <a:srgbClr val="FF0000"/>
                 </a:solidFill>
+                <a:latin typeface="+mn-lt"/>
               </a:rPr>
               <a:t> expression)</a:t>
             </a:r>
@@ -10767,1007 +11266,11 @@
               <a:solidFill>
                 <a:srgbClr val="FF0000"/>
               </a:solidFill>
+              <a:latin typeface="+mn-lt"/>
             </a:endParaRPr>
           </a:p>
         </p:txBody>
       </p:sp>
-      <p:graphicFrame>
-        <p:nvGraphicFramePr>
-          <p:cNvPr id="4" name="Table 3"/>
-          <p:cNvGraphicFramePr>
-            <a:graphicFrameLocks noGrp="1"/>
-          </p:cNvGraphicFramePr>
-          <p:nvPr>
-            <p:extLst>
-              <p:ext uri="{D42A27DB-BD31-4B8C-83A1-F6EECF244321}">
-                <p14:modId xmlns:p14="http://schemas.microsoft.com/office/powerpoint/2010/main" val="4266263096"/>
-              </p:ext>
-            </p:extLst>
-          </p:nvPr>
-        </p:nvGraphicFramePr>
-        <p:xfrm>
-          <a:off x="1331640" y="1654017"/>
-          <a:ext cx="6696748" cy="3987540"/>
-        </p:xfrm>
-        <a:graphic>
-          <a:graphicData uri="http://schemas.openxmlformats.org/drawingml/2006/table">
-            <a:tbl>
-              <a:tblPr/>
-              <a:tblGrid>
-                <a:gridCol w="1674187">
-                  <a:extLst>
-                    <a:ext uri="{9D8B030D-6E8A-4147-A177-3AD203B41FA5}">
-                      <a16:colId xmlns:a16="http://schemas.microsoft.com/office/drawing/2014/main" val="3886729575"/>
-                    </a:ext>
-                  </a:extLst>
-                </a:gridCol>
-                <a:gridCol w="1674187">
-                  <a:extLst>
-                    <a:ext uri="{9D8B030D-6E8A-4147-A177-3AD203B41FA5}">
-                      <a16:colId xmlns:a16="http://schemas.microsoft.com/office/drawing/2014/main" val="647650561"/>
-                    </a:ext>
-                  </a:extLst>
-                </a:gridCol>
-                <a:gridCol w="1674187">
-                  <a:extLst>
-                    <a:ext uri="{9D8B030D-6E8A-4147-A177-3AD203B41FA5}">
-                      <a16:colId xmlns:a16="http://schemas.microsoft.com/office/drawing/2014/main" val="1767356684"/>
-                    </a:ext>
-                  </a:extLst>
-                </a:gridCol>
-                <a:gridCol w="1674187">
-                  <a:extLst>
-                    <a:ext uri="{9D8B030D-6E8A-4147-A177-3AD203B41FA5}">
-                      <a16:colId xmlns:a16="http://schemas.microsoft.com/office/drawing/2014/main" val="2444873677"/>
-                    </a:ext>
-                  </a:extLst>
-                </a:gridCol>
-              </a:tblGrid>
-              <a:tr h="530809">
-                <a:tc>
-                  <a:txBody>
-                    <a:bodyPr/>
-                    <a:lstStyle/>
-                    <a:p>
-                      <a:r>
-                        <a:rPr lang="en-US" sz="1500" b="1" dirty="0">
-                          <a:solidFill>
-                            <a:srgbClr val="000000"/>
-                          </a:solidFill>
-                          <a:effectLst/>
-                        </a:rPr>
-                        <a:t>Interface</a:t>
-                      </a:r>
-                    </a:p>
-                  </a:txBody>
-                  <a:tcPr marL="70127" marR="70127" marT="32366" marB="32366" anchor="ctr">
-                    <a:lnL w="6350" cap="flat" cmpd="sng" algn="ctr">
-                      <a:solidFill>
-                        <a:srgbClr val="D6D6D6"/>
-                      </a:solidFill>
-                      <a:prstDash val="solid"/>
-                      <a:round/>
-                      <a:headEnd type="none" w="med" len="med"/>
-                      <a:tailEnd type="none" w="med" len="med"/>
-                    </a:lnL>
-                    <a:lnR w="6350" cap="flat" cmpd="sng" algn="ctr">
-                      <a:solidFill>
-                        <a:srgbClr val="D6D6D6"/>
-                      </a:solidFill>
-                      <a:prstDash val="solid"/>
-                      <a:round/>
-                      <a:headEnd type="none" w="med" len="med"/>
-                      <a:tailEnd type="none" w="med" len="med"/>
-                    </a:lnR>
-                    <a:lnT w="6350" cap="flat" cmpd="sng" algn="ctr">
-                      <a:solidFill>
-                        <a:srgbClr val="D6D6D6"/>
-                      </a:solidFill>
-                      <a:prstDash val="solid"/>
-                      <a:round/>
-                      <a:headEnd type="none" w="med" len="med"/>
-                      <a:tailEnd type="none" w="med" len="med"/>
-                    </a:lnT>
-                    <a:lnB w="6350" cap="flat" cmpd="sng" algn="ctr">
-                      <a:solidFill>
-                        <a:srgbClr val="D6D6D6"/>
-                      </a:solidFill>
-                      <a:prstDash val="solid"/>
-                      <a:round/>
-                      <a:headEnd type="none" w="med" len="med"/>
-                      <a:tailEnd type="none" w="med" len="med"/>
-                    </a:lnB>
-                    <a:solidFill>
-                      <a:srgbClr val="FFFFFF"/>
-                    </a:solidFill>
-                  </a:tcPr>
-                </a:tc>
-                <a:tc>
-                  <a:txBody>
-                    <a:bodyPr/>
-                    <a:lstStyle/>
-                    <a:p>
-                      <a:r>
-                        <a:rPr lang="en-US" sz="1500" b="1">
-                          <a:solidFill>
-                            <a:srgbClr val="000000"/>
-                          </a:solidFill>
-                          <a:effectLst/>
-                        </a:rPr>
-                        <a:t>Entrée</a:t>
-                      </a:r>
-                    </a:p>
-                  </a:txBody>
-                  <a:tcPr marL="70127" marR="70127" marT="32366" marB="32366" anchor="ctr">
-                    <a:lnL w="6350" cap="flat" cmpd="sng" algn="ctr">
-                      <a:solidFill>
-                        <a:srgbClr val="D6D6D6"/>
-                      </a:solidFill>
-                      <a:prstDash val="solid"/>
-                      <a:round/>
-                      <a:headEnd type="none" w="med" len="med"/>
-                      <a:tailEnd type="none" w="med" len="med"/>
-                    </a:lnL>
-                    <a:lnR w="6350" cap="flat" cmpd="sng" algn="ctr">
-                      <a:solidFill>
-                        <a:srgbClr val="D6D6D6"/>
-                      </a:solidFill>
-                      <a:prstDash val="solid"/>
-                      <a:round/>
-                      <a:headEnd type="none" w="med" len="med"/>
-                      <a:tailEnd type="none" w="med" len="med"/>
-                    </a:lnR>
-                    <a:lnT w="6350" cap="flat" cmpd="sng" algn="ctr">
-                      <a:solidFill>
-                        <a:srgbClr val="D6D6D6"/>
-                      </a:solidFill>
-                      <a:prstDash val="solid"/>
-                      <a:round/>
-                      <a:headEnd type="none" w="med" len="med"/>
-                      <a:tailEnd type="none" w="med" len="med"/>
-                    </a:lnT>
-                    <a:lnB w="6350" cap="flat" cmpd="sng" algn="ctr">
-                      <a:solidFill>
-                        <a:srgbClr val="D6D6D6"/>
-                      </a:solidFill>
-                      <a:prstDash val="solid"/>
-                      <a:round/>
-                      <a:headEnd type="none" w="med" len="med"/>
-                      <a:tailEnd type="none" w="med" len="med"/>
-                    </a:lnB>
-                    <a:solidFill>
-                      <a:srgbClr val="FFFFFF"/>
-                    </a:solidFill>
-                  </a:tcPr>
-                </a:tc>
-                <a:tc>
-                  <a:txBody>
-                    <a:bodyPr/>
-                    <a:lstStyle/>
-                    <a:p>
-                      <a:r>
-                        <a:rPr lang="en-US" sz="1500" b="1">
-                          <a:solidFill>
-                            <a:srgbClr val="000000"/>
-                          </a:solidFill>
-                          <a:effectLst/>
-                        </a:rPr>
-                        <a:t>Sortie</a:t>
-                      </a:r>
-                    </a:p>
-                  </a:txBody>
-                  <a:tcPr marL="70127" marR="70127" marT="32366" marB="32366" anchor="ctr">
-                    <a:lnL w="6350" cap="flat" cmpd="sng" algn="ctr">
-                      <a:solidFill>
-                        <a:srgbClr val="D6D6D6"/>
-                      </a:solidFill>
-                      <a:prstDash val="solid"/>
-                      <a:round/>
-                      <a:headEnd type="none" w="med" len="med"/>
-                      <a:tailEnd type="none" w="med" len="med"/>
-                    </a:lnL>
-                    <a:lnR w="6350" cap="flat" cmpd="sng" algn="ctr">
-                      <a:solidFill>
-                        <a:srgbClr val="D6D6D6"/>
-                      </a:solidFill>
-                      <a:prstDash val="solid"/>
-                      <a:round/>
-                      <a:headEnd type="none" w="med" len="med"/>
-                      <a:tailEnd type="none" w="med" len="med"/>
-                    </a:lnR>
-                    <a:lnT w="6350" cap="flat" cmpd="sng" algn="ctr">
-                      <a:solidFill>
-                        <a:srgbClr val="D6D6D6"/>
-                      </a:solidFill>
-                      <a:prstDash val="solid"/>
-                      <a:round/>
-                      <a:headEnd type="none" w="med" len="med"/>
-                      <a:tailEnd type="none" w="med" len="med"/>
-                    </a:lnT>
-                    <a:lnB w="6350" cap="flat" cmpd="sng" algn="ctr">
-                      <a:solidFill>
-                        <a:srgbClr val="D6D6D6"/>
-                      </a:solidFill>
-                      <a:prstDash val="solid"/>
-                      <a:round/>
-                      <a:headEnd type="none" w="med" len="med"/>
-                      <a:tailEnd type="none" w="med" len="med"/>
-                    </a:lnB>
-                    <a:solidFill>
-                      <a:srgbClr val="FFFFFF"/>
-                    </a:solidFill>
-                  </a:tcPr>
-                </a:tc>
-                <a:tc>
-                  <a:txBody>
-                    <a:bodyPr/>
-                    <a:lstStyle/>
-                    <a:p>
-                      <a:r>
-                        <a:rPr lang="en-US" sz="1500" b="1">
-                          <a:solidFill>
-                            <a:srgbClr val="000000"/>
-                          </a:solidFill>
-                          <a:effectLst/>
-                        </a:rPr>
-                        <a:t>Usage</a:t>
-                      </a:r>
-                    </a:p>
-                  </a:txBody>
-                  <a:tcPr marL="70127" marR="70127" marT="32366" marB="32366" anchor="ctr">
-                    <a:lnL w="6350" cap="flat" cmpd="sng" algn="ctr">
-                      <a:solidFill>
-                        <a:srgbClr val="D6D6D6"/>
-                      </a:solidFill>
-                      <a:prstDash val="solid"/>
-                      <a:round/>
-                      <a:headEnd type="none" w="med" len="med"/>
-                      <a:tailEnd type="none" w="med" len="med"/>
-                    </a:lnL>
-                    <a:lnR w="6350" cap="flat" cmpd="sng" algn="ctr">
-                      <a:solidFill>
-                        <a:srgbClr val="D6D6D6"/>
-                      </a:solidFill>
-                      <a:prstDash val="solid"/>
-                      <a:round/>
-                      <a:headEnd type="none" w="med" len="med"/>
-                      <a:tailEnd type="none" w="med" len="med"/>
-                    </a:lnR>
-                    <a:lnT w="6350" cap="flat" cmpd="sng" algn="ctr">
-                      <a:solidFill>
-                        <a:srgbClr val="D6D6D6"/>
-                      </a:solidFill>
-                      <a:prstDash val="solid"/>
-                      <a:round/>
-                      <a:headEnd type="none" w="med" len="med"/>
-                      <a:tailEnd type="none" w="med" len="med"/>
-                    </a:lnT>
-                    <a:lnB w="6350" cap="flat" cmpd="sng" algn="ctr">
-                      <a:solidFill>
-                        <a:srgbClr val="D6D6D6"/>
-                      </a:solidFill>
-                      <a:prstDash val="solid"/>
-                      <a:round/>
-                      <a:headEnd type="none" w="med" len="med"/>
-                      <a:tailEnd type="none" w="med" len="med"/>
-                    </a:lnB>
-                    <a:solidFill>
-                      <a:srgbClr val="FFFFFF"/>
-                    </a:solidFill>
-                  </a:tcPr>
-                </a:tc>
-                <a:extLst>
-                  <a:ext uri="{0D108BD9-81ED-4DB2-BD59-A6C34878D82A}">
-                    <a16:rowId xmlns:a16="http://schemas.microsoft.com/office/drawing/2014/main" val="347353883"/>
-                  </a:ext>
-                </a:extLst>
-              </a:tr>
-              <a:tr h="996885">
-                <a:tc>
-                  <a:txBody>
-                    <a:bodyPr/>
-                    <a:lstStyle/>
-                    <a:p>
-                      <a:r>
-                        <a:rPr lang="en-US" sz="1500" b="1" dirty="0">
-                          <a:effectLst/>
-                        </a:rPr>
-                        <a:t>Predicate&lt;T&gt;</a:t>
-                      </a:r>
-                    </a:p>
-                  </a:txBody>
-                  <a:tcPr marL="70127" marR="70127" marT="32366" marB="32366" anchor="ctr">
-                    <a:lnL w="6350" cap="flat" cmpd="sng" algn="ctr">
-                      <a:solidFill>
-                        <a:srgbClr val="D6D6D6"/>
-                      </a:solidFill>
-                      <a:prstDash val="solid"/>
-                      <a:round/>
-                      <a:headEnd type="none" w="med" len="med"/>
-                      <a:tailEnd type="none" w="med" len="med"/>
-                    </a:lnL>
-                    <a:lnR w="6350" cap="flat" cmpd="sng" algn="ctr">
-                      <a:solidFill>
-                        <a:srgbClr val="D6D6D6"/>
-                      </a:solidFill>
-                      <a:prstDash val="solid"/>
-                      <a:round/>
-                      <a:headEnd type="none" w="med" len="med"/>
-                      <a:tailEnd type="none" w="med" len="med"/>
-                    </a:lnR>
-                    <a:lnT w="6350" cap="flat" cmpd="sng" algn="ctr">
-                      <a:solidFill>
-                        <a:srgbClr val="D6D6D6"/>
-                      </a:solidFill>
-                      <a:prstDash val="solid"/>
-                      <a:round/>
-                      <a:headEnd type="none" w="med" len="med"/>
-                      <a:tailEnd type="none" w="med" len="med"/>
-                    </a:lnT>
-                    <a:lnB w="6350" cap="flat" cmpd="sng" algn="ctr">
-                      <a:solidFill>
-                        <a:srgbClr val="D6D6D6"/>
-                      </a:solidFill>
-                      <a:prstDash val="solid"/>
-                      <a:round/>
-                      <a:headEnd type="none" w="med" len="med"/>
-                      <a:tailEnd type="none" w="med" len="med"/>
-                    </a:lnB>
-                    <a:solidFill>
-                      <a:srgbClr val="FFFFFF"/>
-                    </a:solidFill>
-                  </a:tcPr>
-                </a:tc>
-                <a:tc>
-                  <a:txBody>
-                    <a:bodyPr/>
-                    <a:lstStyle/>
-                    <a:p>
-                      <a:r>
-                        <a:rPr lang="en-US" sz="1500" dirty="0">
-                          <a:effectLst/>
-                        </a:rPr>
-                        <a:t>T</a:t>
-                      </a:r>
-                    </a:p>
-                  </a:txBody>
-                  <a:tcPr marL="70127" marR="70127" marT="32366" marB="32366" anchor="ctr">
-                    <a:lnL w="6350" cap="flat" cmpd="sng" algn="ctr">
-                      <a:solidFill>
-                        <a:srgbClr val="D6D6D6"/>
-                      </a:solidFill>
-                      <a:prstDash val="solid"/>
-                      <a:round/>
-                      <a:headEnd type="none" w="med" len="med"/>
-                      <a:tailEnd type="none" w="med" len="med"/>
-                    </a:lnL>
-                    <a:lnR w="6350" cap="flat" cmpd="sng" algn="ctr">
-                      <a:solidFill>
-                        <a:srgbClr val="D6D6D6"/>
-                      </a:solidFill>
-                      <a:prstDash val="solid"/>
-                      <a:round/>
-                      <a:headEnd type="none" w="med" len="med"/>
-                      <a:tailEnd type="none" w="med" len="med"/>
-                    </a:lnR>
-                    <a:lnT w="6350" cap="flat" cmpd="sng" algn="ctr">
-                      <a:solidFill>
-                        <a:srgbClr val="D6D6D6"/>
-                      </a:solidFill>
-                      <a:prstDash val="solid"/>
-                      <a:round/>
-                      <a:headEnd type="none" w="med" len="med"/>
-                      <a:tailEnd type="none" w="med" len="med"/>
-                    </a:lnT>
-                    <a:lnB w="6350" cap="flat" cmpd="sng" algn="ctr">
-                      <a:solidFill>
-                        <a:srgbClr val="D6D6D6"/>
-                      </a:solidFill>
-                      <a:prstDash val="solid"/>
-                      <a:round/>
-                      <a:headEnd type="none" w="med" len="med"/>
-                      <a:tailEnd type="none" w="med" len="med"/>
-                    </a:lnB>
-                    <a:solidFill>
-                      <a:srgbClr val="FFFFFF"/>
-                    </a:solidFill>
-                  </a:tcPr>
-                </a:tc>
-                <a:tc>
-                  <a:txBody>
-                    <a:bodyPr/>
-                    <a:lstStyle/>
-                    <a:p>
-                      <a:r>
-                        <a:rPr lang="en-US" sz="1500" dirty="0" err="1">
-                          <a:effectLst/>
-                        </a:rPr>
-                        <a:t>boolean</a:t>
-                      </a:r>
-                      <a:endParaRPr lang="en-US" sz="1500" dirty="0">
-                        <a:effectLst/>
-                      </a:endParaRPr>
-                    </a:p>
-                  </a:txBody>
-                  <a:tcPr marL="70127" marR="70127" marT="32366" marB="32366" anchor="ctr">
-                    <a:lnL w="6350" cap="flat" cmpd="sng" algn="ctr">
-                      <a:solidFill>
-                        <a:srgbClr val="D6D6D6"/>
-                      </a:solidFill>
-                      <a:prstDash val="solid"/>
-                      <a:round/>
-                      <a:headEnd type="none" w="med" len="med"/>
-                      <a:tailEnd type="none" w="med" len="med"/>
-                    </a:lnL>
-                    <a:lnR w="6350" cap="flat" cmpd="sng" algn="ctr">
-                      <a:solidFill>
-                        <a:srgbClr val="D6D6D6"/>
-                      </a:solidFill>
-                      <a:prstDash val="solid"/>
-                      <a:round/>
-                      <a:headEnd type="none" w="med" len="med"/>
-                      <a:tailEnd type="none" w="med" len="med"/>
-                    </a:lnR>
-                    <a:lnT w="6350" cap="flat" cmpd="sng" algn="ctr">
-                      <a:solidFill>
-                        <a:srgbClr val="D6D6D6"/>
-                      </a:solidFill>
-                      <a:prstDash val="solid"/>
-                      <a:round/>
-                      <a:headEnd type="none" w="med" len="med"/>
-                      <a:tailEnd type="none" w="med" len="med"/>
-                    </a:lnT>
-                    <a:lnB w="6350" cap="flat" cmpd="sng" algn="ctr">
-                      <a:solidFill>
-                        <a:srgbClr val="D6D6D6"/>
-                      </a:solidFill>
-                      <a:prstDash val="solid"/>
-                      <a:round/>
-                      <a:headEnd type="none" w="med" len="med"/>
-                      <a:tailEnd type="none" w="med" len="med"/>
-                    </a:lnB>
-                    <a:solidFill>
-                      <a:srgbClr val="FFFFFF"/>
-                    </a:solidFill>
-                  </a:tcPr>
-                </a:tc>
-                <a:tc>
-                  <a:txBody>
-                    <a:bodyPr/>
-                    <a:lstStyle/>
-                    <a:p>
-                      <a:r>
-                        <a:rPr lang="en-US" sz="1500">
-                          <a:effectLst/>
-                        </a:rPr>
-                        <a:t>Tester une condition</a:t>
-                      </a:r>
-                    </a:p>
-                  </a:txBody>
-                  <a:tcPr marL="70127" marR="70127" marT="32366" marB="32366" anchor="ctr">
-                    <a:lnL w="6350" cap="flat" cmpd="sng" algn="ctr">
-                      <a:solidFill>
-                        <a:srgbClr val="D6D6D6"/>
-                      </a:solidFill>
-                      <a:prstDash val="solid"/>
-                      <a:round/>
-                      <a:headEnd type="none" w="med" len="med"/>
-                      <a:tailEnd type="none" w="med" len="med"/>
-                    </a:lnL>
-                    <a:lnR w="6350" cap="flat" cmpd="sng" algn="ctr">
-                      <a:solidFill>
-                        <a:srgbClr val="D6D6D6"/>
-                      </a:solidFill>
-                      <a:prstDash val="solid"/>
-                      <a:round/>
-                      <a:headEnd type="none" w="med" len="med"/>
-                      <a:tailEnd type="none" w="med" len="med"/>
-                    </a:lnR>
-                    <a:lnT w="6350" cap="flat" cmpd="sng" algn="ctr">
-                      <a:solidFill>
-                        <a:srgbClr val="D6D6D6"/>
-                      </a:solidFill>
-                      <a:prstDash val="solid"/>
-                      <a:round/>
-                      <a:headEnd type="none" w="med" len="med"/>
-                      <a:tailEnd type="none" w="med" len="med"/>
-                    </a:lnT>
-                    <a:lnB w="6350" cap="flat" cmpd="sng" algn="ctr">
-                      <a:solidFill>
-                        <a:srgbClr val="D6D6D6"/>
-                      </a:solidFill>
-                      <a:prstDash val="solid"/>
-                      <a:round/>
-                      <a:headEnd type="none" w="med" len="med"/>
-                      <a:tailEnd type="none" w="med" len="med"/>
-                    </a:lnB>
-                    <a:solidFill>
-                      <a:srgbClr val="FFFFFF"/>
-                    </a:solidFill>
-                  </a:tcPr>
-                </a:tc>
-                <a:extLst>
-                  <a:ext uri="{0D108BD9-81ED-4DB2-BD59-A6C34878D82A}">
-                    <a16:rowId xmlns:a16="http://schemas.microsoft.com/office/drawing/2014/main" val="3226352889"/>
-                  </a:ext>
-                </a:extLst>
-              </a:tr>
-              <a:tr h="1229923">
-                <a:tc>
-                  <a:txBody>
-                    <a:bodyPr/>
-                    <a:lstStyle/>
-                    <a:p>
-                      <a:r>
-                        <a:rPr lang="en-US" sz="1500" b="1" dirty="0">
-                          <a:effectLst/>
-                        </a:rPr>
-                        <a:t>Function&lt;T,R&gt;</a:t>
-                      </a:r>
-                    </a:p>
-                  </a:txBody>
-                  <a:tcPr marL="70127" marR="70127" marT="32366" marB="32366" anchor="ctr">
-                    <a:lnL w="6350" cap="flat" cmpd="sng" algn="ctr">
-                      <a:solidFill>
-                        <a:srgbClr val="D6D6D6"/>
-                      </a:solidFill>
-                      <a:prstDash val="solid"/>
-                      <a:round/>
-                      <a:headEnd type="none" w="med" len="med"/>
-                      <a:tailEnd type="none" w="med" len="med"/>
-                    </a:lnL>
-                    <a:lnR w="6350" cap="flat" cmpd="sng" algn="ctr">
-                      <a:solidFill>
-                        <a:srgbClr val="D6D6D6"/>
-                      </a:solidFill>
-                      <a:prstDash val="solid"/>
-                      <a:round/>
-                      <a:headEnd type="none" w="med" len="med"/>
-                      <a:tailEnd type="none" w="med" len="med"/>
-                    </a:lnR>
-                    <a:lnT w="6350" cap="flat" cmpd="sng" algn="ctr">
-                      <a:solidFill>
-                        <a:srgbClr val="D6D6D6"/>
-                      </a:solidFill>
-                      <a:prstDash val="solid"/>
-                      <a:round/>
-                      <a:headEnd type="none" w="med" len="med"/>
-                      <a:tailEnd type="none" w="med" len="med"/>
-                    </a:lnT>
-                    <a:lnB w="6350" cap="flat" cmpd="sng" algn="ctr">
-                      <a:solidFill>
-                        <a:srgbClr val="D6D6D6"/>
-                      </a:solidFill>
-                      <a:prstDash val="solid"/>
-                      <a:round/>
-                      <a:headEnd type="none" w="med" len="med"/>
-                      <a:tailEnd type="none" w="med" len="med"/>
-                    </a:lnB>
-                    <a:solidFill>
-                      <a:srgbClr val="FFFFFF"/>
-                    </a:solidFill>
-                  </a:tcPr>
-                </a:tc>
-                <a:tc>
-                  <a:txBody>
-                    <a:bodyPr/>
-                    <a:lstStyle/>
-                    <a:p>
-                      <a:r>
-                        <a:rPr lang="en-US" sz="1500" dirty="0">
-                          <a:effectLst/>
-                        </a:rPr>
-                        <a:t>T</a:t>
-                      </a:r>
-                    </a:p>
-                  </a:txBody>
-                  <a:tcPr marL="70127" marR="70127" marT="32366" marB="32366" anchor="ctr">
-                    <a:lnL w="6350" cap="flat" cmpd="sng" algn="ctr">
-                      <a:solidFill>
-                        <a:srgbClr val="D6D6D6"/>
-                      </a:solidFill>
-                      <a:prstDash val="solid"/>
-                      <a:round/>
-                      <a:headEnd type="none" w="med" len="med"/>
-                      <a:tailEnd type="none" w="med" len="med"/>
-                    </a:lnL>
-                    <a:lnR w="6350" cap="flat" cmpd="sng" algn="ctr">
-                      <a:solidFill>
-                        <a:srgbClr val="D6D6D6"/>
-                      </a:solidFill>
-                      <a:prstDash val="solid"/>
-                      <a:round/>
-                      <a:headEnd type="none" w="med" len="med"/>
-                      <a:tailEnd type="none" w="med" len="med"/>
-                    </a:lnR>
-                    <a:lnT w="6350" cap="flat" cmpd="sng" algn="ctr">
-                      <a:solidFill>
-                        <a:srgbClr val="D6D6D6"/>
-                      </a:solidFill>
-                      <a:prstDash val="solid"/>
-                      <a:round/>
-                      <a:headEnd type="none" w="med" len="med"/>
-                      <a:tailEnd type="none" w="med" len="med"/>
-                    </a:lnT>
-                    <a:lnB w="6350" cap="flat" cmpd="sng" algn="ctr">
-                      <a:solidFill>
-                        <a:srgbClr val="D6D6D6"/>
-                      </a:solidFill>
-                      <a:prstDash val="solid"/>
-                      <a:round/>
-                      <a:headEnd type="none" w="med" len="med"/>
-                      <a:tailEnd type="none" w="med" len="med"/>
-                    </a:lnB>
-                    <a:solidFill>
-                      <a:srgbClr val="FFFFFF"/>
-                    </a:solidFill>
-                  </a:tcPr>
-                </a:tc>
-                <a:tc>
-                  <a:txBody>
-                    <a:bodyPr/>
-                    <a:lstStyle/>
-                    <a:p>
-                      <a:r>
-                        <a:rPr lang="en-US" sz="1500" dirty="0">
-                          <a:effectLst/>
-                        </a:rPr>
-                        <a:t>R</a:t>
-                      </a:r>
-                    </a:p>
-                  </a:txBody>
-                  <a:tcPr marL="70127" marR="70127" marT="32366" marB="32366" anchor="ctr">
-                    <a:lnL w="6350" cap="flat" cmpd="sng" algn="ctr">
-                      <a:solidFill>
-                        <a:srgbClr val="D6D6D6"/>
-                      </a:solidFill>
-                      <a:prstDash val="solid"/>
-                      <a:round/>
-                      <a:headEnd type="none" w="med" len="med"/>
-                      <a:tailEnd type="none" w="med" len="med"/>
-                    </a:lnL>
-                    <a:lnR w="6350" cap="flat" cmpd="sng" algn="ctr">
-                      <a:solidFill>
-                        <a:srgbClr val="D6D6D6"/>
-                      </a:solidFill>
-                      <a:prstDash val="solid"/>
-                      <a:round/>
-                      <a:headEnd type="none" w="med" len="med"/>
-                      <a:tailEnd type="none" w="med" len="med"/>
-                    </a:lnR>
-                    <a:lnT w="6350" cap="flat" cmpd="sng" algn="ctr">
-                      <a:solidFill>
-                        <a:srgbClr val="D6D6D6"/>
-                      </a:solidFill>
-                      <a:prstDash val="solid"/>
-                      <a:round/>
-                      <a:headEnd type="none" w="med" len="med"/>
-                      <a:tailEnd type="none" w="med" len="med"/>
-                    </a:lnT>
-                    <a:lnB w="6350" cap="flat" cmpd="sng" algn="ctr">
-                      <a:solidFill>
-                        <a:srgbClr val="D6D6D6"/>
-                      </a:solidFill>
-                      <a:prstDash val="solid"/>
-                      <a:round/>
-                      <a:headEnd type="none" w="med" len="med"/>
-                      <a:tailEnd type="none" w="med" len="med"/>
-                    </a:lnB>
-                    <a:solidFill>
-                      <a:srgbClr val="FFFFFF"/>
-                    </a:solidFill>
-                  </a:tcPr>
-                </a:tc>
-                <a:tc>
-                  <a:txBody>
-                    <a:bodyPr/>
-                    <a:lstStyle/>
-                    <a:p>
-                      <a:r>
-                        <a:rPr lang="en-US" sz="1500">
-                          <a:effectLst/>
-                        </a:rPr>
-                        <a:t>Transformer un élément</a:t>
-                      </a:r>
-                    </a:p>
-                  </a:txBody>
-                  <a:tcPr marL="70127" marR="70127" marT="32366" marB="32366" anchor="ctr">
-                    <a:lnL w="6350" cap="flat" cmpd="sng" algn="ctr">
-                      <a:solidFill>
-                        <a:srgbClr val="D6D6D6"/>
-                      </a:solidFill>
-                      <a:prstDash val="solid"/>
-                      <a:round/>
-                      <a:headEnd type="none" w="med" len="med"/>
-                      <a:tailEnd type="none" w="med" len="med"/>
-                    </a:lnL>
-                    <a:lnR w="6350" cap="flat" cmpd="sng" algn="ctr">
-                      <a:solidFill>
-                        <a:srgbClr val="D6D6D6"/>
-                      </a:solidFill>
-                      <a:prstDash val="solid"/>
-                      <a:round/>
-                      <a:headEnd type="none" w="med" len="med"/>
-                      <a:tailEnd type="none" w="med" len="med"/>
-                    </a:lnR>
-                    <a:lnT w="6350" cap="flat" cmpd="sng" algn="ctr">
-                      <a:solidFill>
-                        <a:srgbClr val="D6D6D6"/>
-                      </a:solidFill>
-                      <a:prstDash val="solid"/>
-                      <a:round/>
-                      <a:headEnd type="none" w="med" len="med"/>
-                      <a:tailEnd type="none" w="med" len="med"/>
-                    </a:lnT>
-                    <a:lnB w="6350" cap="flat" cmpd="sng" algn="ctr">
-                      <a:solidFill>
-                        <a:srgbClr val="D6D6D6"/>
-                      </a:solidFill>
-                      <a:prstDash val="solid"/>
-                      <a:round/>
-                      <a:headEnd type="none" w="med" len="med"/>
-                      <a:tailEnd type="none" w="med" len="med"/>
-                    </a:lnB>
-                    <a:solidFill>
-                      <a:srgbClr val="FFFFFF"/>
-                    </a:solidFill>
-                  </a:tcPr>
-                </a:tc>
-                <a:extLst>
-                  <a:ext uri="{0D108BD9-81ED-4DB2-BD59-A6C34878D82A}">
-                    <a16:rowId xmlns:a16="http://schemas.microsoft.com/office/drawing/2014/main" val="3343540537"/>
-                  </a:ext>
-                </a:extLst>
-              </a:tr>
-              <a:tr h="1229923">
-                <a:tc>
-                  <a:txBody>
-                    <a:bodyPr/>
-                    <a:lstStyle/>
-                    <a:p>
-                      <a:r>
-                        <a:rPr lang="en-US" sz="1500" b="1" dirty="0">
-                          <a:effectLst/>
-                        </a:rPr>
-                        <a:t>Consumer&lt;T&gt;</a:t>
-                      </a:r>
-                    </a:p>
-                  </a:txBody>
-                  <a:tcPr marL="70127" marR="70127" marT="32366" marB="32366" anchor="ctr">
-                    <a:lnL w="6350" cap="flat" cmpd="sng" algn="ctr">
-                      <a:solidFill>
-                        <a:srgbClr val="D6D6D6"/>
-                      </a:solidFill>
-                      <a:prstDash val="solid"/>
-                      <a:round/>
-                      <a:headEnd type="none" w="med" len="med"/>
-                      <a:tailEnd type="none" w="med" len="med"/>
-                    </a:lnL>
-                    <a:lnR w="6350" cap="flat" cmpd="sng" algn="ctr">
-                      <a:solidFill>
-                        <a:srgbClr val="D6D6D6"/>
-                      </a:solidFill>
-                      <a:prstDash val="solid"/>
-                      <a:round/>
-                      <a:headEnd type="none" w="med" len="med"/>
-                      <a:tailEnd type="none" w="med" len="med"/>
-                    </a:lnR>
-                    <a:lnT w="6350" cap="flat" cmpd="sng" algn="ctr">
-                      <a:solidFill>
-                        <a:srgbClr val="D6D6D6"/>
-                      </a:solidFill>
-                      <a:prstDash val="solid"/>
-                      <a:round/>
-                      <a:headEnd type="none" w="med" len="med"/>
-                      <a:tailEnd type="none" w="med" len="med"/>
-                    </a:lnT>
-                    <a:lnB w="6350" cap="flat" cmpd="sng" algn="ctr">
-                      <a:solidFill>
-                        <a:srgbClr val="D6D6D6"/>
-                      </a:solidFill>
-                      <a:prstDash val="solid"/>
-                      <a:round/>
-                      <a:headEnd type="none" w="med" len="med"/>
-                      <a:tailEnd type="none" w="med" len="med"/>
-                    </a:lnB>
-                    <a:solidFill>
-                      <a:srgbClr val="FFFFFF"/>
-                    </a:solidFill>
-                  </a:tcPr>
-                </a:tc>
-                <a:tc>
-                  <a:txBody>
-                    <a:bodyPr/>
-                    <a:lstStyle/>
-                    <a:p>
-                      <a:r>
-                        <a:rPr lang="en-US" sz="1500">
-                          <a:effectLst/>
-                        </a:rPr>
-                        <a:t>T</a:t>
-                      </a:r>
-                    </a:p>
-                  </a:txBody>
-                  <a:tcPr marL="70127" marR="70127" marT="32366" marB="32366" anchor="ctr">
-                    <a:lnL w="6350" cap="flat" cmpd="sng" algn="ctr">
-                      <a:solidFill>
-                        <a:srgbClr val="D6D6D6"/>
-                      </a:solidFill>
-                      <a:prstDash val="solid"/>
-                      <a:round/>
-                      <a:headEnd type="none" w="med" len="med"/>
-                      <a:tailEnd type="none" w="med" len="med"/>
-                    </a:lnL>
-                    <a:lnR w="6350" cap="flat" cmpd="sng" algn="ctr">
-                      <a:solidFill>
-                        <a:srgbClr val="D6D6D6"/>
-                      </a:solidFill>
-                      <a:prstDash val="solid"/>
-                      <a:round/>
-                      <a:headEnd type="none" w="med" len="med"/>
-                      <a:tailEnd type="none" w="med" len="med"/>
-                    </a:lnR>
-                    <a:lnT w="6350" cap="flat" cmpd="sng" algn="ctr">
-                      <a:solidFill>
-                        <a:srgbClr val="D6D6D6"/>
-                      </a:solidFill>
-                      <a:prstDash val="solid"/>
-                      <a:round/>
-                      <a:headEnd type="none" w="med" len="med"/>
-                      <a:tailEnd type="none" w="med" len="med"/>
-                    </a:lnT>
-                    <a:lnB w="6350" cap="flat" cmpd="sng" algn="ctr">
-                      <a:solidFill>
-                        <a:srgbClr val="D6D6D6"/>
-                      </a:solidFill>
-                      <a:prstDash val="solid"/>
-                      <a:round/>
-                      <a:headEnd type="none" w="med" len="med"/>
-                      <a:tailEnd type="none" w="med" len="med"/>
-                    </a:lnB>
-                    <a:solidFill>
-                      <a:srgbClr val="FFFFFF"/>
-                    </a:solidFill>
-                  </a:tcPr>
-                </a:tc>
-                <a:tc>
-                  <a:txBody>
-                    <a:bodyPr/>
-                    <a:lstStyle/>
-                    <a:p>
-                      <a:r>
-                        <a:rPr lang="en-US" sz="1500" dirty="0">
-                          <a:effectLst/>
-                        </a:rPr>
-                        <a:t>void</a:t>
-                      </a:r>
-                    </a:p>
-                  </a:txBody>
-                  <a:tcPr marL="70127" marR="70127" marT="32366" marB="32366" anchor="ctr">
-                    <a:lnL w="6350" cap="flat" cmpd="sng" algn="ctr">
-                      <a:solidFill>
-                        <a:srgbClr val="D6D6D6"/>
-                      </a:solidFill>
-                      <a:prstDash val="solid"/>
-                      <a:round/>
-                      <a:headEnd type="none" w="med" len="med"/>
-                      <a:tailEnd type="none" w="med" len="med"/>
-                    </a:lnL>
-                    <a:lnR w="6350" cap="flat" cmpd="sng" algn="ctr">
-                      <a:solidFill>
-                        <a:srgbClr val="D6D6D6"/>
-                      </a:solidFill>
-                      <a:prstDash val="solid"/>
-                      <a:round/>
-                      <a:headEnd type="none" w="med" len="med"/>
-                      <a:tailEnd type="none" w="med" len="med"/>
-                    </a:lnR>
-                    <a:lnT w="6350" cap="flat" cmpd="sng" algn="ctr">
-                      <a:solidFill>
-                        <a:srgbClr val="D6D6D6"/>
-                      </a:solidFill>
-                      <a:prstDash val="solid"/>
-                      <a:round/>
-                      <a:headEnd type="none" w="med" len="med"/>
-                      <a:tailEnd type="none" w="med" len="med"/>
-                    </a:lnT>
-                    <a:lnB w="6350" cap="flat" cmpd="sng" algn="ctr">
-                      <a:solidFill>
-                        <a:srgbClr val="D6D6D6"/>
-                      </a:solidFill>
-                      <a:prstDash val="solid"/>
-                      <a:round/>
-                      <a:headEnd type="none" w="med" len="med"/>
-                      <a:tailEnd type="none" w="med" len="med"/>
-                    </a:lnB>
-                    <a:solidFill>
-                      <a:srgbClr val="FFFFFF"/>
-                    </a:solidFill>
-                  </a:tcPr>
-                </a:tc>
-                <a:tc>
-                  <a:txBody>
-                    <a:bodyPr/>
-                    <a:lstStyle/>
-                    <a:p>
-                      <a:r>
-                        <a:rPr lang="en-US" sz="1500" dirty="0" err="1">
-                          <a:effectLst/>
-                        </a:rPr>
-                        <a:t>Consommer</a:t>
-                      </a:r>
-                      <a:r>
-                        <a:rPr lang="en-US" sz="1500" dirty="0">
-                          <a:effectLst/>
-                        </a:rPr>
-                        <a:t> (ex: </a:t>
-                      </a:r>
-                      <a:r>
-                        <a:rPr lang="en-US" sz="1500" dirty="0" err="1">
-                          <a:effectLst/>
-                        </a:rPr>
-                        <a:t>afficher</a:t>
-                      </a:r>
-                      <a:r>
-                        <a:rPr lang="en-US" sz="1500" dirty="0">
-                          <a:effectLst/>
-                        </a:rPr>
-                        <a:t>)</a:t>
-                      </a:r>
-                    </a:p>
-                  </a:txBody>
-                  <a:tcPr marL="70127" marR="70127" marT="32366" marB="32366" anchor="ctr">
-                    <a:lnL w="6350" cap="flat" cmpd="sng" algn="ctr">
-                      <a:solidFill>
-                        <a:srgbClr val="D6D6D6"/>
-                      </a:solidFill>
-                      <a:prstDash val="solid"/>
-                      <a:round/>
-                      <a:headEnd type="none" w="med" len="med"/>
-                      <a:tailEnd type="none" w="med" len="med"/>
-                    </a:lnL>
-                    <a:lnR w="6350" cap="flat" cmpd="sng" algn="ctr">
-                      <a:solidFill>
-                        <a:srgbClr val="D6D6D6"/>
-                      </a:solidFill>
-                      <a:prstDash val="solid"/>
-                      <a:round/>
-                      <a:headEnd type="none" w="med" len="med"/>
-                      <a:tailEnd type="none" w="med" len="med"/>
-                    </a:lnR>
-                    <a:lnT w="6350" cap="flat" cmpd="sng" algn="ctr">
-                      <a:solidFill>
-                        <a:srgbClr val="D6D6D6"/>
-                      </a:solidFill>
-                      <a:prstDash val="solid"/>
-                      <a:round/>
-                      <a:headEnd type="none" w="med" len="med"/>
-                      <a:tailEnd type="none" w="med" len="med"/>
-                    </a:lnT>
-                    <a:lnB w="6350" cap="flat" cmpd="sng" algn="ctr">
-                      <a:solidFill>
-                        <a:srgbClr val="D6D6D6"/>
-                      </a:solidFill>
-                      <a:prstDash val="solid"/>
-                      <a:round/>
-                      <a:headEnd type="none" w="med" len="med"/>
-                      <a:tailEnd type="none" w="med" len="med"/>
-                    </a:lnB>
-                    <a:solidFill>
-                      <a:srgbClr val="FFFFFF"/>
-                    </a:solidFill>
-                  </a:tcPr>
-                </a:tc>
-                <a:extLst>
-                  <a:ext uri="{0D108BD9-81ED-4DB2-BD59-A6C34878D82A}">
-                    <a16:rowId xmlns:a16="http://schemas.microsoft.com/office/drawing/2014/main" val="1292434906"/>
-                  </a:ext>
-                </a:extLst>
-              </a:tr>
-            </a:tbl>
-          </a:graphicData>
-        </a:graphic>
-      </p:graphicFrame>
       <p:sp>
         <p:nvSpPr>
           <p:cNvPr id="5" name="TextBox 4"/>
@@ -11777,7 +11280,7 @@
         <p:spPr>
           <a:xfrm>
             <a:off x="826316" y="910461"/>
-            <a:ext cx="8064896" cy="646331"/>
+            <a:ext cx="8064896" cy="1015663"/>
           </a:xfrm>
           <a:prstGeom prst="rect">
             <a:avLst/>
@@ -11790,93 +11293,171 @@
           </a:bodyPr>
           <a:lstStyle/>
           <a:p>
-            <a:r>
-              <a:rPr lang="en-US" b="1" dirty="0" smtClean="0"/>
+            <a:pPr algn="just"/>
+            <a:r>
+              <a:rPr lang="en-US" sz="2000" b="1" dirty="0" smtClean="0">
+                <a:latin typeface="Times New Roman" panose="02020603050405020304" pitchFamily="18" charset="0"/>
+                <a:cs typeface="Times New Roman" panose="02020603050405020304" pitchFamily="18" charset="0"/>
+              </a:rPr>
               <a:t>Interface </a:t>
             </a:r>
             <a:r>
-              <a:rPr lang="en-US" b="1" dirty="0" err="1" smtClean="0"/>
+              <a:rPr lang="en-US" sz="2000" b="1" dirty="0" err="1" smtClean="0">
+                <a:latin typeface="Times New Roman" panose="02020603050405020304" pitchFamily="18" charset="0"/>
+                <a:cs typeface="Times New Roman" panose="02020603050405020304" pitchFamily="18" charset="0"/>
+              </a:rPr>
               <a:t>Fonctionelles</a:t>
             </a:r>
             <a:r>
-              <a:rPr lang="en-US" b="1" dirty="0" smtClean="0"/>
+              <a:rPr lang="en-US" sz="2000" b="1" dirty="0" smtClean="0">
+                <a:latin typeface="Times New Roman" panose="02020603050405020304" pitchFamily="18" charset="0"/>
+                <a:cs typeface="Times New Roman" panose="02020603050405020304" pitchFamily="18" charset="0"/>
+              </a:rPr>
               <a:t> (</a:t>
             </a:r>
             <a:r>
-              <a:rPr lang="en-US" b="1" dirty="0" err="1" smtClean="0"/>
+              <a:rPr lang="en-US" sz="2000" b="1" dirty="0" err="1" smtClean="0">
+                <a:latin typeface="Times New Roman" panose="02020603050405020304" pitchFamily="18" charset="0"/>
+                <a:cs typeface="Times New Roman" panose="02020603050405020304" pitchFamily="18" charset="0"/>
+              </a:rPr>
               <a:t>possede</a:t>
             </a:r>
             <a:r>
-              <a:rPr lang="en-US" b="1" dirty="0" smtClean="0"/>
+              <a:rPr lang="en-US" sz="2000" b="1" dirty="0" smtClean="0">
+                <a:latin typeface="Times New Roman" panose="02020603050405020304" pitchFamily="18" charset="0"/>
+                <a:cs typeface="Times New Roman" panose="02020603050405020304" pitchFamily="18" charset="0"/>
+              </a:rPr>
               <a:t> </a:t>
             </a:r>
             <a:r>
-              <a:rPr lang="en-US" b="1" dirty="0" err="1" smtClean="0"/>
+              <a:rPr lang="en-US" sz="2000" b="1" dirty="0" err="1" smtClean="0">
+                <a:latin typeface="Times New Roman" panose="02020603050405020304" pitchFamily="18" charset="0"/>
+                <a:cs typeface="Times New Roman" panose="02020603050405020304" pitchFamily="18" charset="0"/>
+              </a:rPr>
               <a:t>une</a:t>
             </a:r>
             <a:r>
-              <a:rPr lang="en-US" b="1" dirty="0" smtClean="0"/>
+              <a:rPr lang="en-US" sz="2000" b="1" dirty="0" smtClean="0">
+                <a:latin typeface="Times New Roman" panose="02020603050405020304" pitchFamily="18" charset="0"/>
+                <a:cs typeface="Times New Roman" panose="02020603050405020304" pitchFamily="18" charset="0"/>
+              </a:rPr>
               <a:t> </a:t>
             </a:r>
             <a:r>
-              <a:rPr lang="en-US" b="1" dirty="0" err="1" smtClean="0"/>
+              <a:rPr lang="en-US" sz="2000" b="1" dirty="0" err="1" smtClean="0">
+                <a:latin typeface="Times New Roman" panose="02020603050405020304" pitchFamily="18" charset="0"/>
+                <a:cs typeface="Times New Roman" panose="02020603050405020304" pitchFamily="18" charset="0"/>
+              </a:rPr>
               <a:t>seule</a:t>
             </a:r>
             <a:r>
-              <a:rPr lang="en-US" b="1" dirty="0" smtClean="0"/>
+              <a:rPr lang="en-US" sz="2000" b="1" dirty="0" smtClean="0">
+                <a:latin typeface="Times New Roman" panose="02020603050405020304" pitchFamily="18" charset="0"/>
+                <a:cs typeface="Times New Roman" panose="02020603050405020304" pitchFamily="18" charset="0"/>
+              </a:rPr>
               <a:t> </a:t>
             </a:r>
             <a:r>
-              <a:rPr lang="en-US" b="1" dirty="0" err="1" smtClean="0"/>
+              <a:rPr lang="en-US" sz="2000" b="1" dirty="0" err="1" smtClean="0">
+                <a:latin typeface="Times New Roman" panose="02020603050405020304" pitchFamily="18" charset="0"/>
+                <a:cs typeface="Times New Roman" panose="02020603050405020304" pitchFamily="18" charset="0"/>
+              </a:rPr>
               <a:t>methode</a:t>
             </a:r>
             <a:r>
-              <a:rPr lang="en-US" b="1" dirty="0" smtClean="0"/>
+              <a:rPr lang="en-US" sz="2000" b="1" dirty="0" smtClean="0">
+                <a:latin typeface="Times New Roman" panose="02020603050405020304" pitchFamily="18" charset="0"/>
+                <a:cs typeface="Times New Roman" panose="02020603050405020304" pitchFamily="18" charset="0"/>
+              </a:rPr>
               <a:t> </a:t>
             </a:r>
             <a:r>
-              <a:rPr lang="en-US" b="1" dirty="0" err="1" smtClean="0"/>
+              <a:rPr lang="en-US" sz="2000" b="1" dirty="0" err="1" smtClean="0">
+                <a:latin typeface="Times New Roman" panose="02020603050405020304" pitchFamily="18" charset="0"/>
+                <a:cs typeface="Times New Roman" panose="02020603050405020304" pitchFamily="18" charset="0"/>
+              </a:rPr>
               <a:t>abstariate</a:t>
             </a:r>
             <a:r>
-              <a:rPr lang="en-US" b="1" dirty="0" smtClean="0"/>
-              <a:t>) </a:t>
-            </a:r>
-          </a:p>
-          <a:p>
-            <a:r>
-              <a:rPr lang="en-US" dirty="0" smtClean="0"/>
+              <a:rPr lang="en-US" sz="2000" b="1" dirty="0" smtClean="0">
+                <a:latin typeface="Times New Roman" panose="02020603050405020304" pitchFamily="18" charset="0"/>
+                <a:cs typeface="Times New Roman" panose="02020603050405020304" pitchFamily="18" charset="0"/>
+              </a:rPr>
+              <a:t>)</a:t>
+            </a:r>
+          </a:p>
+          <a:p>
+            <a:pPr algn="just"/>
+            <a:r>
+              <a:rPr lang="en-US" sz="2000" b="1" dirty="0" smtClean="0">
+                <a:latin typeface="Times New Roman" panose="02020603050405020304" pitchFamily="18" charset="0"/>
+                <a:cs typeface="Times New Roman" panose="02020603050405020304" pitchFamily="18" charset="0"/>
+              </a:rPr>
+              <a:t> </a:t>
+            </a:r>
+          </a:p>
+          <a:p>
+            <a:pPr algn="just"/>
+            <a:r>
+              <a:rPr lang="en-US" sz="2000" dirty="0" smtClean="0">
+                <a:latin typeface="Times New Roman" panose="02020603050405020304" pitchFamily="18" charset="0"/>
+                <a:cs typeface="Times New Roman" panose="02020603050405020304" pitchFamily="18" charset="0"/>
+              </a:rPr>
               <a:t>Java 8 </a:t>
             </a:r>
             <a:r>
-              <a:rPr lang="en-US" dirty="0" err="1" smtClean="0"/>
+              <a:rPr lang="en-US" sz="2000" dirty="0" err="1" smtClean="0">
+                <a:latin typeface="Times New Roman" panose="02020603050405020304" pitchFamily="18" charset="0"/>
+                <a:cs typeface="Times New Roman" panose="02020603050405020304" pitchFamily="18" charset="0"/>
+              </a:rPr>
               <a:t>fournit</a:t>
             </a:r>
             <a:r>
-              <a:rPr lang="en-US" dirty="0" smtClean="0"/>
+              <a:rPr lang="en-US" sz="2000" dirty="0" smtClean="0">
+                <a:latin typeface="Times New Roman" panose="02020603050405020304" pitchFamily="18" charset="0"/>
+                <a:cs typeface="Times New Roman" panose="02020603050405020304" pitchFamily="18" charset="0"/>
+              </a:rPr>
               <a:t> des interfaces </a:t>
             </a:r>
             <a:r>
-              <a:rPr lang="en-US" dirty="0" err="1" smtClean="0"/>
+              <a:rPr lang="en-US" sz="2000" dirty="0" err="1" smtClean="0">
+                <a:latin typeface="Times New Roman" panose="02020603050405020304" pitchFamily="18" charset="0"/>
+                <a:cs typeface="Times New Roman" panose="02020603050405020304" pitchFamily="18" charset="0"/>
+              </a:rPr>
               <a:t>pretes</a:t>
             </a:r>
             <a:r>
-              <a:rPr lang="en-US" dirty="0" smtClean="0"/>
+              <a:rPr lang="en-US" sz="2000" dirty="0" smtClean="0">
+                <a:latin typeface="Times New Roman" panose="02020603050405020304" pitchFamily="18" charset="0"/>
+                <a:cs typeface="Times New Roman" panose="02020603050405020304" pitchFamily="18" charset="0"/>
+              </a:rPr>
               <a:t> a </a:t>
             </a:r>
             <a:r>
-              <a:rPr lang="en-US" dirty="0" err="1" smtClean="0"/>
+              <a:rPr lang="en-US" sz="2000" dirty="0" err="1" smtClean="0">
+                <a:latin typeface="Times New Roman" panose="02020603050405020304" pitchFamily="18" charset="0"/>
+                <a:cs typeface="Times New Roman" panose="02020603050405020304" pitchFamily="18" charset="0"/>
+              </a:rPr>
               <a:t>etre</a:t>
             </a:r>
             <a:r>
-              <a:rPr lang="en-US" dirty="0" smtClean="0"/>
+              <a:rPr lang="en-US" sz="2000" dirty="0" smtClean="0">
+                <a:latin typeface="Times New Roman" panose="02020603050405020304" pitchFamily="18" charset="0"/>
+                <a:cs typeface="Times New Roman" panose="02020603050405020304" pitchFamily="18" charset="0"/>
+              </a:rPr>
               <a:t> employees avec </a:t>
             </a:r>
             <a:r>
-              <a:rPr lang="en-US" dirty="0" err="1" smtClean="0"/>
+              <a:rPr lang="en-US" sz="2000" dirty="0" err="1" smtClean="0">
+                <a:latin typeface="Times New Roman" panose="02020603050405020304" pitchFamily="18" charset="0"/>
+                <a:cs typeface="Times New Roman" panose="02020603050405020304" pitchFamily="18" charset="0"/>
+              </a:rPr>
               <a:t>lamda</a:t>
             </a:r>
-            <a:endParaRPr lang="en-US" dirty="0"/>
+            <a:endParaRPr lang="en-US" sz="2000" dirty="0">
+              <a:latin typeface="Times New Roman" panose="02020603050405020304" pitchFamily="18" charset="0"/>
+              <a:cs typeface="Times New Roman" panose="02020603050405020304" pitchFamily="18" charset="0"/>
+            </a:endParaRPr>
           </a:p>
         </p:txBody>
       </p:sp>
@@ -11895,7 +11476,7 @@
           <p:nvPr/>
         </p:nvPicPr>
         <p:blipFill>
-          <a:blip r:embed="rId2" cstate="print">
+          <a:blip r:embed="rId3" cstate="print">
             <a:extLst>
               <a:ext uri="{28A0092B-C50C-407E-A947-70E740481C1C}">
                 <a14:useLocalDpi xmlns:a14="http://schemas.microsoft.com/office/drawing/2010/main" val="0"/>
@@ -11916,6 +11497,661 @@
           </a:prstGeom>
         </p:spPr>
       </p:pic>
+      <p:graphicFrame>
+        <p:nvGraphicFramePr>
+          <p:cNvPr id="7" name="Table 6"/>
+          <p:cNvGraphicFramePr>
+            <a:graphicFrameLocks noGrp="1"/>
+          </p:cNvGraphicFramePr>
+          <p:nvPr>
+            <p:extLst>
+              <p:ext uri="{D42A27DB-BD31-4B8C-83A1-F6EECF244321}">
+                <p14:modId xmlns:p14="http://schemas.microsoft.com/office/powerpoint/2010/main" val="3201951205"/>
+              </p:ext>
+            </p:extLst>
+          </p:nvPr>
+        </p:nvGraphicFramePr>
+        <p:xfrm>
+          <a:off x="956620" y="2348880"/>
+          <a:ext cx="7287788" cy="3744416"/>
+        </p:xfrm>
+        <a:graphic>
+          <a:graphicData uri="http://schemas.openxmlformats.org/drawingml/2006/table">
+            <a:tbl>
+              <a:tblPr/>
+              <a:tblGrid>
+                <a:gridCol w="1821947">
+                  <a:extLst>
+                    <a:ext uri="{9D8B030D-6E8A-4147-A177-3AD203B41FA5}">
+                      <a16:colId xmlns:a16="http://schemas.microsoft.com/office/drawing/2014/main" val="1600148068"/>
+                    </a:ext>
+                  </a:extLst>
+                </a:gridCol>
+                <a:gridCol w="1821947">
+                  <a:extLst>
+                    <a:ext uri="{9D8B030D-6E8A-4147-A177-3AD203B41FA5}">
+                      <a16:colId xmlns:a16="http://schemas.microsoft.com/office/drawing/2014/main" val="2655763201"/>
+                    </a:ext>
+                  </a:extLst>
+                </a:gridCol>
+                <a:gridCol w="1821947">
+                  <a:extLst>
+                    <a:ext uri="{9D8B030D-6E8A-4147-A177-3AD203B41FA5}">
+                      <a16:colId xmlns:a16="http://schemas.microsoft.com/office/drawing/2014/main" val="4015933991"/>
+                    </a:ext>
+                  </a:extLst>
+                </a:gridCol>
+                <a:gridCol w="1821947">
+                  <a:extLst>
+                    <a:ext uri="{9D8B030D-6E8A-4147-A177-3AD203B41FA5}">
+                      <a16:colId xmlns:a16="http://schemas.microsoft.com/office/drawing/2014/main" val="1168528271"/>
+                    </a:ext>
+                  </a:extLst>
+                </a:gridCol>
+              </a:tblGrid>
+              <a:tr h="468052">
+                <a:tc>
+                  <a:txBody>
+                    <a:bodyPr/>
+                    <a:lstStyle/>
+                    <a:p>
+                      <a:r>
+                        <a:rPr lang="en-US" b="1" dirty="0"/>
+                        <a:t>Interface</a:t>
+                      </a:r>
+                    </a:p>
+                  </a:txBody>
+                  <a:tcPr anchor="ctr">
+                    <a:lnL>
+                      <a:noFill/>
+                    </a:lnL>
+                    <a:lnR>
+                      <a:noFill/>
+                    </a:lnR>
+                    <a:lnT>
+                      <a:noFill/>
+                    </a:lnT>
+                    <a:lnB>
+                      <a:noFill/>
+                    </a:lnB>
+                  </a:tcPr>
+                </a:tc>
+                <a:tc>
+                  <a:txBody>
+                    <a:bodyPr/>
+                    <a:lstStyle/>
+                    <a:p>
+                      <a:r>
+                        <a:rPr lang="en-US" b="1"/>
+                        <a:t>Entrée</a:t>
+                      </a:r>
+                    </a:p>
+                  </a:txBody>
+                  <a:tcPr anchor="ctr">
+                    <a:lnL>
+                      <a:noFill/>
+                    </a:lnL>
+                    <a:lnR>
+                      <a:noFill/>
+                    </a:lnR>
+                    <a:lnT>
+                      <a:noFill/>
+                    </a:lnT>
+                    <a:lnB>
+                      <a:noFill/>
+                    </a:lnB>
+                  </a:tcPr>
+                </a:tc>
+                <a:tc>
+                  <a:txBody>
+                    <a:bodyPr/>
+                    <a:lstStyle/>
+                    <a:p>
+                      <a:r>
+                        <a:rPr lang="en-US" b="1"/>
+                        <a:t>Sortie</a:t>
+                      </a:r>
+                    </a:p>
+                  </a:txBody>
+                  <a:tcPr anchor="ctr">
+                    <a:lnL>
+                      <a:noFill/>
+                    </a:lnL>
+                    <a:lnR>
+                      <a:noFill/>
+                    </a:lnR>
+                    <a:lnT>
+                      <a:noFill/>
+                    </a:lnT>
+                    <a:lnB>
+                      <a:noFill/>
+                    </a:lnB>
+                  </a:tcPr>
+                </a:tc>
+                <a:tc>
+                  <a:txBody>
+                    <a:bodyPr/>
+                    <a:lstStyle/>
+                    <a:p>
+                      <a:r>
+                        <a:rPr lang="en-US" b="1" dirty="0"/>
+                        <a:t>Usage</a:t>
+                      </a:r>
+                    </a:p>
+                  </a:txBody>
+                  <a:tcPr anchor="ctr">
+                    <a:lnL>
+                      <a:noFill/>
+                    </a:lnL>
+                    <a:lnR>
+                      <a:noFill/>
+                    </a:lnR>
+                    <a:lnT>
+                      <a:noFill/>
+                    </a:lnT>
+                    <a:lnB>
+                      <a:noFill/>
+                    </a:lnB>
+                  </a:tcPr>
+                </a:tc>
+                <a:extLst>
+                  <a:ext uri="{0D108BD9-81ED-4DB2-BD59-A6C34878D82A}">
+                    <a16:rowId xmlns:a16="http://schemas.microsoft.com/office/drawing/2014/main" val="4151235679"/>
+                  </a:ext>
+                </a:extLst>
+              </a:tr>
+              <a:tr h="819091">
+                <a:tc>
+                  <a:txBody>
+                    <a:bodyPr/>
+                    <a:lstStyle/>
+                    <a:p>
+                      <a:r>
+                        <a:rPr lang="en-US" b="1" dirty="0"/>
+                        <a:t>Predicate&lt;T&gt;</a:t>
+                      </a:r>
+                    </a:p>
+                  </a:txBody>
+                  <a:tcPr anchor="ctr">
+                    <a:lnL>
+                      <a:noFill/>
+                    </a:lnL>
+                    <a:lnR>
+                      <a:noFill/>
+                    </a:lnR>
+                    <a:lnT>
+                      <a:noFill/>
+                    </a:lnT>
+                    <a:lnB>
+                      <a:noFill/>
+                    </a:lnB>
+                  </a:tcPr>
+                </a:tc>
+                <a:tc>
+                  <a:txBody>
+                    <a:bodyPr/>
+                    <a:lstStyle/>
+                    <a:p>
+                      <a:r>
+                        <a:rPr lang="en-US" dirty="0"/>
+                        <a:t>T</a:t>
+                      </a:r>
+                    </a:p>
+                  </a:txBody>
+                  <a:tcPr anchor="ctr">
+                    <a:lnL>
+                      <a:noFill/>
+                    </a:lnL>
+                    <a:lnR>
+                      <a:noFill/>
+                    </a:lnR>
+                    <a:lnT>
+                      <a:noFill/>
+                    </a:lnT>
+                    <a:lnB>
+                      <a:noFill/>
+                    </a:lnB>
+                  </a:tcPr>
+                </a:tc>
+                <a:tc>
+                  <a:txBody>
+                    <a:bodyPr/>
+                    <a:lstStyle/>
+                    <a:p>
+                      <a:r>
+                        <a:rPr lang="en-US" dirty="0" err="1"/>
+                        <a:t>boolean</a:t>
+                      </a:r>
+                      <a:endParaRPr lang="en-US" dirty="0"/>
+                    </a:p>
+                  </a:txBody>
+                  <a:tcPr anchor="ctr">
+                    <a:lnL>
+                      <a:noFill/>
+                    </a:lnL>
+                    <a:lnR>
+                      <a:noFill/>
+                    </a:lnR>
+                    <a:lnT>
+                      <a:noFill/>
+                    </a:lnT>
+                    <a:lnB>
+                      <a:noFill/>
+                    </a:lnB>
+                  </a:tcPr>
+                </a:tc>
+                <a:tc>
+                  <a:txBody>
+                    <a:bodyPr/>
+                    <a:lstStyle/>
+                    <a:p>
+                      <a:r>
+                        <a:rPr lang="en-US" b="1" dirty="0"/>
+                        <a:t>Tester </a:t>
+                      </a:r>
+                      <a:r>
+                        <a:rPr lang="en-US" b="1" dirty="0" err="1"/>
+                        <a:t>une</a:t>
+                      </a:r>
+                      <a:r>
+                        <a:rPr lang="en-US" b="1" dirty="0"/>
+                        <a:t> condition</a:t>
+                      </a:r>
+                    </a:p>
+                  </a:txBody>
+                  <a:tcPr anchor="ctr">
+                    <a:lnL>
+                      <a:noFill/>
+                    </a:lnL>
+                    <a:lnR>
+                      <a:noFill/>
+                    </a:lnR>
+                    <a:lnT>
+                      <a:noFill/>
+                    </a:lnT>
+                    <a:lnB>
+                      <a:noFill/>
+                    </a:lnB>
+                  </a:tcPr>
+                </a:tc>
+                <a:extLst>
+                  <a:ext uri="{0D108BD9-81ED-4DB2-BD59-A6C34878D82A}">
+                    <a16:rowId xmlns:a16="http://schemas.microsoft.com/office/drawing/2014/main" val="785003703"/>
+                  </a:ext>
+                </a:extLst>
+              </a:tr>
+              <a:tr h="819091">
+                <a:tc>
+                  <a:txBody>
+                    <a:bodyPr/>
+                    <a:lstStyle/>
+                    <a:p>
+                      <a:r>
+                        <a:rPr lang="en-US" b="1" dirty="0"/>
+                        <a:t>Function&lt;T,R&gt;</a:t>
+                      </a:r>
+                    </a:p>
+                  </a:txBody>
+                  <a:tcPr anchor="ctr">
+                    <a:lnL>
+                      <a:noFill/>
+                    </a:lnL>
+                    <a:lnR>
+                      <a:noFill/>
+                    </a:lnR>
+                    <a:lnT>
+                      <a:noFill/>
+                    </a:lnT>
+                    <a:lnB>
+                      <a:noFill/>
+                    </a:lnB>
+                  </a:tcPr>
+                </a:tc>
+                <a:tc>
+                  <a:txBody>
+                    <a:bodyPr/>
+                    <a:lstStyle/>
+                    <a:p>
+                      <a:r>
+                        <a:rPr lang="en-US" b="1" dirty="0"/>
+                        <a:t>T</a:t>
+                      </a:r>
+                    </a:p>
+                  </a:txBody>
+                  <a:tcPr anchor="ctr">
+                    <a:lnL>
+                      <a:noFill/>
+                    </a:lnL>
+                    <a:lnR>
+                      <a:noFill/>
+                    </a:lnR>
+                    <a:lnT>
+                      <a:noFill/>
+                    </a:lnT>
+                    <a:lnB>
+                      <a:noFill/>
+                    </a:lnB>
+                  </a:tcPr>
+                </a:tc>
+                <a:tc>
+                  <a:txBody>
+                    <a:bodyPr/>
+                    <a:lstStyle/>
+                    <a:p>
+                      <a:r>
+                        <a:rPr lang="en-US" b="1" dirty="0"/>
+                        <a:t>R</a:t>
+                      </a:r>
+                    </a:p>
+                  </a:txBody>
+                  <a:tcPr anchor="ctr">
+                    <a:lnL>
+                      <a:noFill/>
+                    </a:lnL>
+                    <a:lnR>
+                      <a:noFill/>
+                    </a:lnR>
+                    <a:lnT>
+                      <a:noFill/>
+                    </a:lnT>
+                    <a:lnB>
+                      <a:noFill/>
+                    </a:lnB>
+                  </a:tcPr>
+                </a:tc>
+                <a:tc>
+                  <a:txBody>
+                    <a:bodyPr/>
+                    <a:lstStyle/>
+                    <a:p>
+                      <a:r>
+                        <a:rPr lang="en-US" b="1" dirty="0"/>
+                        <a:t>Transformer un </a:t>
+                      </a:r>
+                      <a:r>
+                        <a:rPr lang="en-US" b="1" dirty="0" err="1"/>
+                        <a:t>élément</a:t>
+                      </a:r>
+                      <a:endParaRPr lang="en-US" b="1" dirty="0"/>
+                    </a:p>
+                  </a:txBody>
+                  <a:tcPr anchor="ctr">
+                    <a:lnL>
+                      <a:noFill/>
+                    </a:lnL>
+                    <a:lnR>
+                      <a:noFill/>
+                    </a:lnR>
+                    <a:lnT>
+                      <a:noFill/>
+                    </a:lnT>
+                    <a:lnB>
+                      <a:noFill/>
+                    </a:lnB>
+                  </a:tcPr>
+                </a:tc>
+                <a:extLst>
+                  <a:ext uri="{0D108BD9-81ED-4DB2-BD59-A6C34878D82A}">
+                    <a16:rowId xmlns:a16="http://schemas.microsoft.com/office/drawing/2014/main" val="1599097691"/>
+                  </a:ext>
+                </a:extLst>
+              </a:tr>
+              <a:tr h="819091">
+                <a:tc>
+                  <a:txBody>
+                    <a:bodyPr/>
+                    <a:lstStyle/>
+                    <a:p>
+                      <a:r>
+                        <a:rPr lang="en-US" b="1" dirty="0"/>
+                        <a:t>Consumer&lt;T&gt;</a:t>
+                      </a:r>
+                    </a:p>
+                  </a:txBody>
+                  <a:tcPr anchor="ctr">
+                    <a:lnL>
+                      <a:noFill/>
+                    </a:lnL>
+                    <a:lnR>
+                      <a:noFill/>
+                    </a:lnR>
+                    <a:lnT>
+                      <a:noFill/>
+                    </a:lnT>
+                    <a:lnB>
+                      <a:noFill/>
+                    </a:lnB>
+                  </a:tcPr>
+                </a:tc>
+                <a:tc>
+                  <a:txBody>
+                    <a:bodyPr/>
+                    <a:lstStyle/>
+                    <a:p>
+                      <a:r>
+                        <a:rPr lang="en-US" dirty="0"/>
+                        <a:t>T</a:t>
+                      </a:r>
+                    </a:p>
+                  </a:txBody>
+                  <a:tcPr anchor="ctr">
+                    <a:lnL>
+                      <a:noFill/>
+                    </a:lnL>
+                    <a:lnR>
+                      <a:noFill/>
+                    </a:lnR>
+                    <a:lnT>
+                      <a:noFill/>
+                    </a:lnT>
+                    <a:lnB>
+                      <a:noFill/>
+                    </a:lnB>
+                  </a:tcPr>
+                </a:tc>
+                <a:tc>
+                  <a:txBody>
+                    <a:bodyPr/>
+                    <a:lstStyle/>
+                    <a:p>
+                      <a:r>
+                        <a:rPr lang="en-US" dirty="0"/>
+                        <a:t>void</a:t>
+                      </a:r>
+                    </a:p>
+                  </a:txBody>
+                  <a:tcPr anchor="ctr">
+                    <a:lnL>
+                      <a:noFill/>
+                    </a:lnL>
+                    <a:lnR>
+                      <a:noFill/>
+                    </a:lnR>
+                    <a:lnT>
+                      <a:noFill/>
+                    </a:lnT>
+                    <a:lnB>
+                      <a:noFill/>
+                    </a:lnB>
+                  </a:tcPr>
+                </a:tc>
+                <a:tc>
+                  <a:txBody>
+                    <a:bodyPr/>
+                    <a:lstStyle/>
+                    <a:p>
+                      <a:r>
+                        <a:rPr lang="en-US" b="1" dirty="0" err="1"/>
+                        <a:t>Consommer</a:t>
+                      </a:r>
+                      <a:r>
+                        <a:rPr lang="en-US" b="1" dirty="0"/>
+                        <a:t> (ex: </a:t>
+                      </a:r>
+                      <a:r>
+                        <a:rPr lang="en-US" b="1" dirty="0" err="1"/>
+                        <a:t>afficher</a:t>
+                      </a:r>
+                      <a:r>
+                        <a:rPr lang="en-US" b="1" dirty="0"/>
+                        <a:t>)</a:t>
+                      </a:r>
+                    </a:p>
+                  </a:txBody>
+                  <a:tcPr anchor="ctr">
+                    <a:lnL>
+                      <a:noFill/>
+                    </a:lnL>
+                    <a:lnR>
+                      <a:noFill/>
+                    </a:lnR>
+                    <a:lnT>
+                      <a:noFill/>
+                    </a:lnT>
+                    <a:lnB>
+                      <a:noFill/>
+                    </a:lnB>
+                  </a:tcPr>
+                </a:tc>
+                <a:extLst>
+                  <a:ext uri="{0D108BD9-81ED-4DB2-BD59-A6C34878D82A}">
+                    <a16:rowId xmlns:a16="http://schemas.microsoft.com/office/drawing/2014/main" val="1868978152"/>
+                  </a:ext>
+                </a:extLst>
+              </a:tr>
+              <a:tr h="819091">
+                <a:tc>
+                  <a:txBody>
+                    <a:bodyPr/>
+                    <a:lstStyle/>
+                    <a:p>
+                      <a:r>
+                        <a:rPr lang="en-US" b="1" dirty="0"/>
+                        <a:t>Supplier&lt;T&gt;</a:t>
+                      </a:r>
+                    </a:p>
+                  </a:txBody>
+                  <a:tcPr anchor="ctr">
+                    <a:lnL>
+                      <a:noFill/>
+                    </a:lnL>
+                    <a:lnR>
+                      <a:noFill/>
+                    </a:lnR>
+                    <a:lnT>
+                      <a:noFill/>
+                    </a:lnT>
+                    <a:lnB>
+                      <a:noFill/>
+                    </a:lnB>
+                  </a:tcPr>
+                </a:tc>
+                <a:tc>
+                  <a:txBody>
+                    <a:bodyPr/>
+                    <a:lstStyle/>
+                    <a:p>
+                      <a:r>
+                        <a:rPr lang="en-US" dirty="0" err="1"/>
+                        <a:t>rien</a:t>
+                      </a:r>
+                      <a:endParaRPr lang="en-US" dirty="0"/>
+                    </a:p>
+                  </a:txBody>
+                  <a:tcPr anchor="ctr">
+                    <a:lnL>
+                      <a:noFill/>
+                    </a:lnL>
+                    <a:lnR>
+                      <a:noFill/>
+                    </a:lnR>
+                    <a:lnT>
+                      <a:noFill/>
+                    </a:lnT>
+                    <a:lnB>
+                      <a:noFill/>
+                    </a:lnB>
+                  </a:tcPr>
+                </a:tc>
+                <a:tc>
+                  <a:txBody>
+                    <a:bodyPr/>
+                    <a:lstStyle/>
+                    <a:p>
+                      <a:r>
+                        <a:rPr lang="en-US"/>
+                        <a:t>T</a:t>
+                      </a:r>
+                    </a:p>
+                  </a:txBody>
+                  <a:tcPr anchor="ctr">
+                    <a:lnL>
+                      <a:noFill/>
+                    </a:lnL>
+                    <a:lnR>
+                      <a:noFill/>
+                    </a:lnR>
+                    <a:lnT>
+                      <a:noFill/>
+                    </a:lnT>
+                    <a:lnB>
+                      <a:noFill/>
+                    </a:lnB>
+                  </a:tcPr>
+                </a:tc>
+                <a:tc>
+                  <a:txBody>
+                    <a:bodyPr/>
+                    <a:lstStyle/>
+                    <a:p>
+                      <a:r>
+                        <a:rPr lang="en-US" b="1" dirty="0" err="1"/>
+                        <a:t>Fournir</a:t>
+                      </a:r>
+                      <a:r>
+                        <a:rPr lang="en-US" b="1" dirty="0"/>
+                        <a:t> </a:t>
+                      </a:r>
+                      <a:r>
+                        <a:rPr lang="en-US" b="1" dirty="0" err="1"/>
+                        <a:t>une</a:t>
+                      </a:r>
+                      <a:r>
+                        <a:rPr lang="en-US" b="1" dirty="0"/>
+                        <a:t> </a:t>
+                      </a:r>
+                      <a:r>
+                        <a:rPr lang="en-US" b="1" dirty="0" err="1"/>
+                        <a:t>valeur</a:t>
+                      </a:r>
+                      <a:endParaRPr lang="en-US" b="1" dirty="0"/>
+                    </a:p>
+                  </a:txBody>
+                  <a:tcPr anchor="ctr">
+                    <a:lnL>
+                      <a:noFill/>
+                    </a:lnL>
+                    <a:lnR>
+                      <a:noFill/>
+                    </a:lnR>
+                    <a:lnT>
+                      <a:noFill/>
+                    </a:lnT>
+                    <a:lnB>
+                      <a:noFill/>
+                    </a:lnB>
+                  </a:tcPr>
+                </a:tc>
+                <a:extLst>
+                  <a:ext uri="{0D108BD9-81ED-4DB2-BD59-A6C34878D82A}">
+                    <a16:rowId xmlns:a16="http://schemas.microsoft.com/office/drawing/2014/main" val="531498561"/>
+                  </a:ext>
+                </a:extLst>
+              </a:tr>
+            </a:tbl>
+          </a:graphicData>
+        </a:graphic>
+      </p:graphicFrame>
     </p:spTree>
     <p:extLst>
       <p:ext uri="{BB962C8B-B14F-4D97-AF65-F5344CB8AC3E}">

</xml_diff>